<commit_message>
macOS fixes + live web dashboard
- Fix battery sampling on psutil 7.x (sentinel secsleft) - exposed on real
  laptops with batteries; regression tests cover all psutil battery shapes
- New: arc web - zero-dependency live dashboard (gauges, contract states,
  managed processes before/after, streaming event feed) for demos
- demo/generate_load.sh - CPU load generator to trigger contracts live
- 4 battery regression tests (27 total passing)
- README: PEP 668 venv quickstart for macOS/Homebrew
- PPT: 'Results at a Glance' KPI slide + dashboard demo flow
</commit_message>
<xml_diff>
--- a/docs/ARC_Final_Presentation.pptx
+++ b/docs/ARC_Final_Presentation.pptx
@@ -22,6 +22,7 @@
     <p:sldId id="270" r:id="rId21"/>
     <p:sldId id="271" r:id="rId22"/>
     <p:sldId id="272" r:id="rId23"/>
+    <p:sldId id="273" r:id="rId24"/>
   </p:sldIdLst>
   <p:sldSz cx="12191695" cy="6858000" type="screen4x3"/>
   <p:notesSz cx="6858000" cy="9144000"/>
@@ -3324,7 +3325,7 @@
               </a:defRPr>
             </a:pPr>
             <a:r>
-              <a:t>compile-boost contract, live lifecycle</a:t>
+              <a:t>compile-boost contract + live web dashboard</a:t>
             </a:r>
           </a:p>
         </p:txBody>
@@ -3355,14 +3356,14 @@
               <a:spcAft>
                 <a:spcPts val="800"/>
               </a:spcAft>
-              <a:defRPr sz="1800">
-                <a:solidFill>
-                  <a:srgbClr val="1A365D"/>
-                </a:solidFill>
-              </a:defRPr>
-            </a:pPr>
-            <a:r>
-              <a:t>• 1. gcc/make appears → debounce 1 s → compiler boosted (nice −5), background apps deprioritized</a:t>
+              <a:defRPr sz="1700">
+                <a:solidFill>
+                  <a:srgbClr val="1A365D"/>
+                </a:solidFill>
+              </a:defRPr>
+            </a:pPr>
+            <a:r>
+              <a:t>• 1. python3 -m arc web  → live dashboard: gauges, contract states, event feed</a:t>
             </a:r>
           </a:p>
           <a:p>
@@ -3370,14 +3371,14 @@
               <a:spcAft>
                 <a:spcPts val="800"/>
               </a:spcAft>
-              <a:defRPr sz="1800">
-                <a:solidFill>
-                  <a:srgbClr val="1A365D"/>
-                </a:solidFill>
-              </a:defRPr>
-            </a:pPr>
-            <a:r>
-              <a:t>• 2. Build finishes → trigger clears → original nice/affinity restored exactly</a:t>
+              <a:defRPr sz="1700">
+                <a:solidFill>
+                  <a:srgbClr val="1A365D"/>
+                </a:solidFill>
+              </a:defRPr>
+            </a:pPr>
+            <a:r>
+              <a:t>• 2. gcc/make appears → debounce 1 s → compiler boosted (nice −5), background deprioritized</a:t>
             </a:r>
           </a:p>
           <a:p>
@@ -3385,14 +3386,14 @@
               <a:spcAft>
                 <a:spcPts val="800"/>
               </a:spcAft>
-              <a:defRPr sz="1800">
-                <a:solidFill>
-                  <a:srgbClr val="1A365D"/>
-                </a:solidFill>
-              </a:defRPr>
-            </a:pPr>
-            <a:r>
-              <a:t>• 3. Battery drops below 25% → background workloads suspended; plugged in → resumed</a:t>
+              <a:defRPr sz="1700">
+                <a:solidFill>
+                  <a:srgbClr val="1A365D"/>
+                </a:solidFill>
+              </a:defRPr>
+            </a:pPr>
+            <a:r>
+              <a:t>• 3. Build finishes → trigger clears → original nice/affinity restored exactly</a:t>
             </a:r>
           </a:p>
           <a:p>
@@ -3400,14 +3401,29 @@
               <a:spcAft>
                 <a:spcPts val="800"/>
               </a:spcAft>
-              <a:defRPr sz="1800">
-                <a:solidFill>
-                  <a:srgbClr val="1A365D"/>
-                </a:solidFill>
-              </a:defRPr>
-            </a:pPr>
-            <a:r>
-              <a:t>• 4. Execution log shows every decision: trigger, action with before/after state, restore</a:t>
+              <a:defRPr sz="1700">
+                <a:solidFill>
+                  <a:srgbClr val="1A365D"/>
+                </a:solidFill>
+              </a:defRPr>
+            </a:pPr>
+            <a:r>
+              <a:t>• 4. Battery drops below 25% → background workloads suspended; plugged in → resumed</a:t>
+            </a:r>
+          </a:p>
+          <a:p>
+            <a:pPr>
+              <a:spcAft>
+                <a:spcPts val="800"/>
+              </a:spcAft>
+              <a:defRPr sz="1700">
+                <a:solidFill>
+                  <a:srgbClr val="1A365D"/>
+                </a:solidFill>
+              </a:defRPr>
+            </a:pPr>
+            <a:r>
+              <a:t>• 5. bash demo/generate_load.sh → CPU pressure → cpu-hot-guard fires on screen</a:t>
             </a:r>
           </a:p>
           <a:p>
@@ -3415,7 +3431,7 @@
               <a:spcAft>
                 <a:spcPts val="800"/>
               </a:spcAft>
-              <a:defRPr sz="1500">
+              <a:defRPr sz="1400">
                 <a:solidFill>
                   <a:srgbClr val="1A365D"/>
                 </a:solidFill>
@@ -4815,94 +4831,35 @@
               </a:defRPr>
             </a:pPr>
             <a:r>
-              <a:t>Conclusion &amp; Future Work</a:t>
-            </a:r>
-          </a:p>
-        </p:txBody>
-      </p:sp>
-      <p:sp>
-        <p:nvSpPr>
-          <p:cNvPr id="3" name="TextBox 2"/>
-          <p:cNvSpPr txBox="1"/>
+              <a:t>Results at a Glance</a:t>
+            </a:r>
+          </a:p>
+        </p:txBody>
+      </p:sp>
+      <p:pic>
+        <p:nvPicPr>
+          <p:cNvPr id="3" name="Picture 2" descr="fig_kpi.png"/>
+          <p:cNvPicPr>
+            <a:picLocks noChangeAspect="1"/>
+          </p:cNvPicPr>
           <p:nvPr/>
-        </p:nvSpPr>
-        <p:spPr>
-          <a:xfrm>
-            <a:off x="548640" y="1554480"/>
-            <a:ext cx="11155680" cy="4846320"/>
+        </p:nvPicPr>
+        <p:blipFill>
+          <a:blip r:embed="rId2"/>
+          <a:stretch>
+            <a:fillRect/>
+          </a:stretch>
+        </p:blipFill>
+        <p:spPr>
+          <a:xfrm>
+            <a:off x="1051560" y="1463040"/>
+            <a:ext cx="10058400" cy="4224528"/>
           </a:xfrm>
           <a:prstGeom prst="rect">
             <a:avLst/>
           </a:prstGeom>
-          <a:noFill/>
-        </p:spPr>
-        <p:txBody>
-          <a:bodyPr wrap="square">
-            <a:spAutoFit/>
-          </a:bodyPr>
-          <a:lstStyle/>
-          <a:p>
-            <a:pPr>
-              <a:spcAft>
-                <a:spcPts val="800"/>
-              </a:spcAft>
-              <a:defRPr sz="1800">
-                <a:solidFill>
-                  <a:srgbClr val="1A365D"/>
-                </a:solidFill>
-              </a:defRPr>
-            </a:pPr>
-            <a:r>
-              <a:t>• ARC = monitoring + event detection + contracts + dynamic enforcement + restoration in one layer</a:t>
-            </a:r>
-          </a:p>
-          <a:p>
-            <a:pPr>
-              <a:spcAft>
-                <a:spcPts val="800"/>
-              </a:spcAft>
-              <a:defRPr sz="1800">
-                <a:solidFill>
-                  <a:srgbClr val="1A365D"/>
-                </a:solidFill>
-              </a:defRPr>
-            </a:pPr>
-            <a:r>
-              <a:t>• Demonstrates OS concepts in a real system: scheduling, affinity, signals, cgroups, concurrency, protection</a:t>
-            </a:r>
-          </a:p>
-          <a:p>
-            <a:pPr>
-              <a:spcAft>
-                <a:spcPts val="800"/>
-              </a:spcAft>
-              <a:defRPr sz="1800">
-                <a:solidFill>
-                  <a:srgbClr val="1A365D"/>
-                </a:solidFill>
-              </a:defRPr>
-            </a:pPr>
-            <a:r>
-              <a:t>• Delivers full Review-3 scope: implementation, experimentation, performance evaluation</a:t>
-            </a:r>
-          </a:p>
-          <a:p>
-            <a:pPr>
-              <a:spcAft>
-                <a:spcPts val="800"/>
-              </a:spcAft>
-              <a:defRPr sz="1800">
-                <a:solidFill>
-                  <a:srgbClr val="1A365D"/>
-                </a:solidFill>
-              </a:defRPr>
-            </a:pPr>
-            <a:r>
-              <a:t>• Future: eBPF/proc-connector events, I/O + memory.high controls, contract conflict resolution, TUI/GUI manager, systemd packaging, publication extension</a:t>
-            </a:r>
-          </a:p>
-        </p:txBody>
-      </p:sp>
+        </p:spPr>
+      </p:pic>
     </p:spTree>
   </p:cSld>
   <p:clrMapOvr>
@@ -4968,7 +4925,7 @@
               </a:defRPr>
             </a:pPr>
             <a:r>
-              <a:t>References</a:t>
+              <a:t>Conclusion &amp; Future Work</a:t>
             </a:r>
           </a:p>
         </p:txBody>
@@ -4999,14 +4956,14 @@
               <a:spcAft>
                 <a:spcPts val="800"/>
               </a:spcAft>
-              <a:defRPr sz="1500">
-                <a:solidFill>
-                  <a:srgbClr val="1A365D"/>
-                </a:solidFill>
-              </a:defRPr>
-            </a:pPr>
-            <a:r>
-              <a:t>• [1] Linux Kernel Documentation, "Control Group v2." kernel.org</a:t>
+              <a:defRPr sz="1800">
+                <a:solidFill>
+                  <a:srgbClr val="1A365D"/>
+                </a:solidFill>
+              </a:defRPr>
+            </a:pPr>
+            <a:r>
+              <a:t>• ARC = monitoring + event detection + contracts + dynamic enforcement + restoration in one layer</a:t>
             </a:r>
           </a:p>
           <a:p>
@@ -5014,14 +4971,14 @@
               <a:spcAft>
                 <a:spcPts val="800"/>
               </a:spcAft>
-              <a:defRPr sz="1500">
-                <a:solidFill>
-                  <a:srgbClr val="1A365D"/>
-                </a:solidFill>
-              </a:defRPr>
-            </a:pPr>
-            <a:r>
-              <a:t>• [2] Linux Kernel Documentation, "The /proc Filesystem." kernel.org</a:t>
+              <a:defRPr sz="1800">
+                <a:solidFill>
+                  <a:srgbClr val="1A365D"/>
+                </a:solidFill>
+              </a:defRPr>
+            </a:pPr>
+            <a:r>
+              <a:t>• Demonstrates OS concepts in a real system: scheduling, affinity, signals, cgroups, concurrency, protection</a:t>
             </a:r>
           </a:p>
           <a:p>
@@ -5029,14 +4986,14 @@
               <a:spcAft>
                 <a:spcPts val="800"/>
               </a:spcAft>
-              <a:defRPr sz="1500">
-                <a:solidFill>
-                  <a:srgbClr val="1A365D"/>
-                </a:solidFill>
-              </a:defRPr>
-            </a:pPr>
-            <a:r>
-              <a:t>• [3] Ananicy-cpp: An Auto Nice Daemon. github.com/CachyOS/ananicy-cpp</a:t>
+              <a:defRPr sz="1800">
+                <a:solidFill>
+                  <a:srgbClr val="1A365D"/>
+                </a:solidFill>
+              </a:defRPr>
+            </a:pPr>
+            <a:r>
+              <a:t>• Delivers full Review-3 scope: implementation, experimentation, performance evaluation</a:t>
             </a:r>
           </a:p>
           <a:p>
@@ -5044,14 +5001,14 @@
               <a:spcAft>
                 <a:spcPts val="800"/>
               </a:spcAft>
-              <a:defRPr sz="1500">
-                <a:solidFill>
-                  <a:srgbClr val="1A365D"/>
-                </a:solidFill>
-              </a:defRPr>
-            </a:pPr>
-            <a:r>
-              <a:t>• [4] systemd-oomd.service. freedesktop.org</a:t>
+              <a:defRPr sz="1800">
+                <a:solidFill>
+                  <a:srgbClr val="1A365D"/>
+                </a:solidFill>
+              </a:defRPr>
+            </a:pPr>
+            <a:r>
+              <a:t>• Live web dashboard (arc web) for real-time demonstration of policy decisions</a:t>
             </a:r>
           </a:p>
           <a:p>
@@ -5059,74 +5016,14 @@
               <a:spcAft>
                 <a:spcPts val="800"/>
               </a:spcAft>
-              <a:defRPr sz="1500">
-                <a:solidFill>
-                  <a:srgbClr val="1A365D"/>
-                </a:solidFill>
-              </a:defRPr>
-            </a:pPr>
-            <a:r>
-              <a:t>• [5] TuneD Project Documentation. tuned-project.org</a:t>
-            </a:r>
-          </a:p>
-          <a:p>
-            <a:pPr>
-              <a:spcAft>
-                <a:spcPts val="800"/>
-              </a:spcAft>
-              <a:defRPr sz="1500">
-                <a:solidFill>
-                  <a:srgbClr val="1A365D"/>
-                </a:solidFill>
-              </a:defRPr>
-            </a:pPr>
-            <a:r>
-              <a:t>• [6] S. Goodarzy et al., "SmartOS: Towards Automated Learning and User-Adaptive Resource Allocation in Operating Systems," APSys 2021</a:t>
-            </a:r>
-          </a:p>
-          <a:p>
-            <a:pPr>
-              <a:spcAft>
-                <a:spcPts val="800"/>
-              </a:spcAft>
-              <a:defRPr sz="1500">
-                <a:solidFill>
-                  <a:srgbClr val="1A365D"/>
-                </a:solidFill>
-              </a:defRPr>
-            </a:pPr>
-            <a:r>
-              <a:t>• [7] M. Kerrisk, "sched_setaffinity(2)," Linux man-pages</a:t>
-            </a:r>
-          </a:p>
-          <a:p>
-            <a:pPr>
-              <a:spcAft>
-                <a:spcPts val="800"/>
-              </a:spcAft>
-              <a:defRPr sz="1500">
-                <a:solidFill>
-                  <a:srgbClr val="1A365D"/>
-                </a:solidFill>
-              </a:defRPr>
-            </a:pPr>
-            <a:r>
-              <a:t>• [8] W. M. Stevens, S. A. Rago, Advanced Programming in the UNIX Environment, 3rd ed., 2013</a:t>
-            </a:r>
-          </a:p>
-          <a:p>
-            <a:pPr>
-              <a:spcAft>
-                <a:spcPts val="800"/>
-              </a:spcAft>
-              <a:defRPr sz="1500">
-                <a:solidFill>
-                  <a:srgbClr val="1A365D"/>
-                </a:solidFill>
-              </a:defRPr>
-            </a:pPr>
-            <a:r>
-              <a:t>• [9] psutil documentation. psutil.readthedocs.io</a:t>
+              <a:defRPr sz="1800">
+                <a:solidFill>
+                  <a:srgbClr val="1A365D"/>
+                </a:solidFill>
+              </a:defRPr>
+            </a:pPr>
+            <a:r>
+              <a:t>• Future: eBPF/proc-connector events, I/O + memory.high controls, contract conflict resolution, full management GUI, systemd packaging, publication extension</a:t>
             </a:r>
           </a:p>
         </p:txBody>
@@ -5140,6 +5037,234 @@
 </file>
 
 <file path=ppt/slides/slide17.xml><?xml version="1.0" encoding="utf-8"?>
+<p:sld xmlns:a="http://schemas.openxmlformats.org/drawingml/2006/main" xmlns:p="http://schemas.openxmlformats.org/presentationml/2006/main" xmlns:r="http://schemas.openxmlformats.org/officeDocument/2006/relationships">
+  <p:cSld>
+    <p:spTree>
+      <p:nvGrpSpPr>
+        <p:cNvPr id="1" name=""/>
+        <p:cNvGrpSpPr/>
+        <p:nvPr/>
+      </p:nvGrpSpPr>
+      <p:grpSpPr/>
+      <p:sp>
+        <p:nvSpPr>
+          <p:cNvPr id="2" name="Rectangle 1"/>
+          <p:cNvSpPr/>
+          <p:nvPr/>
+        </p:nvSpPr>
+        <p:spPr>
+          <a:xfrm>
+            <a:off x="0" y="0"/>
+            <a:ext cx="12191695" cy="960120"/>
+          </a:xfrm>
+          <a:prstGeom prst="rect">
+            <a:avLst/>
+          </a:prstGeom>
+          <a:solidFill>
+            <a:srgbClr val="1A365D"/>
+          </a:solidFill>
+          <a:ln>
+            <a:noFill/>
+          </a:ln>
+        </p:spPr>
+        <p:style>
+          <a:lnRef idx="1">
+            <a:schemeClr val="accent1"/>
+          </a:lnRef>
+          <a:fillRef idx="3">
+            <a:schemeClr val="accent1"/>
+          </a:fillRef>
+          <a:effectRef idx="2">
+            <a:schemeClr val="accent1"/>
+          </a:effectRef>
+          <a:fontRef idx="minor">
+            <a:schemeClr val="lt1"/>
+          </a:fontRef>
+        </p:style>
+        <p:txBody>
+          <a:bodyPr rtlCol="0" anchor="ctr" lIns="411480"/>
+          <a:lstStyle/>
+          <a:p>
+            <a:pPr algn="l">
+              <a:defRPr sz="3000" b="1">
+                <a:solidFill>
+                  <a:srgbClr val="FFFFFF"/>
+                </a:solidFill>
+              </a:defRPr>
+            </a:pPr>
+            <a:r>
+              <a:t>References</a:t>
+            </a:r>
+          </a:p>
+        </p:txBody>
+      </p:sp>
+      <p:sp>
+        <p:nvSpPr>
+          <p:cNvPr id="3" name="TextBox 2"/>
+          <p:cNvSpPr txBox="1"/>
+          <p:nvPr/>
+        </p:nvSpPr>
+        <p:spPr>
+          <a:xfrm>
+            <a:off x="548640" y="1554480"/>
+            <a:ext cx="11155680" cy="4846320"/>
+          </a:xfrm>
+          <a:prstGeom prst="rect">
+            <a:avLst/>
+          </a:prstGeom>
+          <a:noFill/>
+        </p:spPr>
+        <p:txBody>
+          <a:bodyPr wrap="square">
+            <a:spAutoFit/>
+          </a:bodyPr>
+          <a:lstStyle/>
+          <a:p>
+            <a:pPr>
+              <a:spcAft>
+                <a:spcPts val="800"/>
+              </a:spcAft>
+              <a:defRPr sz="1500">
+                <a:solidFill>
+                  <a:srgbClr val="1A365D"/>
+                </a:solidFill>
+              </a:defRPr>
+            </a:pPr>
+            <a:r>
+              <a:t>• [1] Linux Kernel Documentation, "Control Group v2." kernel.org</a:t>
+            </a:r>
+          </a:p>
+          <a:p>
+            <a:pPr>
+              <a:spcAft>
+                <a:spcPts val="800"/>
+              </a:spcAft>
+              <a:defRPr sz="1500">
+                <a:solidFill>
+                  <a:srgbClr val="1A365D"/>
+                </a:solidFill>
+              </a:defRPr>
+            </a:pPr>
+            <a:r>
+              <a:t>• [2] Linux Kernel Documentation, "The /proc Filesystem." kernel.org</a:t>
+            </a:r>
+          </a:p>
+          <a:p>
+            <a:pPr>
+              <a:spcAft>
+                <a:spcPts val="800"/>
+              </a:spcAft>
+              <a:defRPr sz="1500">
+                <a:solidFill>
+                  <a:srgbClr val="1A365D"/>
+                </a:solidFill>
+              </a:defRPr>
+            </a:pPr>
+            <a:r>
+              <a:t>• [3] Ananicy-cpp: An Auto Nice Daemon. github.com/CachyOS/ananicy-cpp</a:t>
+            </a:r>
+          </a:p>
+          <a:p>
+            <a:pPr>
+              <a:spcAft>
+                <a:spcPts val="800"/>
+              </a:spcAft>
+              <a:defRPr sz="1500">
+                <a:solidFill>
+                  <a:srgbClr val="1A365D"/>
+                </a:solidFill>
+              </a:defRPr>
+            </a:pPr>
+            <a:r>
+              <a:t>• [4] systemd-oomd.service. freedesktop.org</a:t>
+            </a:r>
+          </a:p>
+          <a:p>
+            <a:pPr>
+              <a:spcAft>
+                <a:spcPts val="800"/>
+              </a:spcAft>
+              <a:defRPr sz="1500">
+                <a:solidFill>
+                  <a:srgbClr val="1A365D"/>
+                </a:solidFill>
+              </a:defRPr>
+            </a:pPr>
+            <a:r>
+              <a:t>• [5] TuneD Project Documentation. tuned-project.org</a:t>
+            </a:r>
+          </a:p>
+          <a:p>
+            <a:pPr>
+              <a:spcAft>
+                <a:spcPts val="800"/>
+              </a:spcAft>
+              <a:defRPr sz="1500">
+                <a:solidFill>
+                  <a:srgbClr val="1A365D"/>
+                </a:solidFill>
+              </a:defRPr>
+            </a:pPr>
+            <a:r>
+              <a:t>• [6] S. Goodarzy et al., "SmartOS: Towards Automated Learning and User-Adaptive Resource Allocation in Operating Systems," APSys 2021</a:t>
+            </a:r>
+          </a:p>
+          <a:p>
+            <a:pPr>
+              <a:spcAft>
+                <a:spcPts val="800"/>
+              </a:spcAft>
+              <a:defRPr sz="1500">
+                <a:solidFill>
+                  <a:srgbClr val="1A365D"/>
+                </a:solidFill>
+              </a:defRPr>
+            </a:pPr>
+            <a:r>
+              <a:t>• [7] M. Kerrisk, "sched_setaffinity(2)," Linux man-pages</a:t>
+            </a:r>
+          </a:p>
+          <a:p>
+            <a:pPr>
+              <a:spcAft>
+                <a:spcPts val="800"/>
+              </a:spcAft>
+              <a:defRPr sz="1500">
+                <a:solidFill>
+                  <a:srgbClr val="1A365D"/>
+                </a:solidFill>
+              </a:defRPr>
+            </a:pPr>
+            <a:r>
+              <a:t>• [8] W. M. Stevens, S. A. Rago, Advanced Programming in the UNIX Environment, 3rd ed., 2013</a:t>
+            </a:r>
+          </a:p>
+          <a:p>
+            <a:pPr>
+              <a:spcAft>
+                <a:spcPts val="800"/>
+              </a:spcAft>
+              <a:defRPr sz="1500">
+                <a:solidFill>
+                  <a:srgbClr val="1A365D"/>
+                </a:solidFill>
+              </a:defRPr>
+            </a:pPr>
+            <a:r>
+              <a:t>• [9] psutil documentation. psutil.readthedocs.io</a:t>
+            </a:r>
+          </a:p>
+        </p:txBody>
+      </p:sp>
+    </p:spTree>
+  </p:cSld>
+  <p:clrMapOvr>
+    <a:masterClrMapping/>
+  </p:clrMapOvr>
+</p:sld>
+</file>
+
+<file path=ppt/slides/slide18.xml><?xml version="1.0" encoding="utf-8"?>
 <p:sld xmlns:a="http://schemas.openxmlformats.org/drawingml/2006/main" xmlns:p="http://schemas.openxmlformats.org/presentationml/2006/main" xmlns:r="http://schemas.openxmlformats.org/officeDocument/2006/relationships">
   <p:cSld>
     <p:spTree>

</xml_diff>

<commit_message>
Cross-platform gap fixes, optimizations, universal demo
Gaps fixed (see GAP_ANALYSIS.md):
- Windows native: SIGSTOP/SIGCONT lazy resolution - suspend/resume/restore
  no longer crash (AttributeError) where POSIX signals don't exist
- WSL: battery bridge via cached Win32_Battery interop - battery-saver
  contract now demonstrable inside WSL
- arc simulate no longer runs forever without --duration
- psutil 7.x battery sentinels (exposed on real laptops)

Optimizations:
- lru_cache regex pool for target matching
- persistent log file handles (no open/close per event)
- process_iter(attrs=...) batched reads

New demo surface (pure Python, identical on WSL/macOS/Windows/Ubuntu):
- python3 -m arc demo  - guided 2-minute demonstration
- demo/generate_load.py - portable CPU load generator
- DEMO_GUIDE.md - per-platform 3-minute demo scripts
- GAP_ANALYSIS.md - gap review & optimization report

Tests: 36 passing (8 new platform-gap + optimization regression tests)
</commit_message>
<xml_diff>
--- a/docs/ARC_Final_Presentation.pptx
+++ b/docs/ARC_Final_Presentation.pptx
@@ -7422,14 +7422,14 @@
               <a:spcAft>
                 <a:spcPts val="800"/>
               </a:spcAft>
-              <a:defRPr sz="1800">
-                <a:solidFill>
-                  <a:srgbClr val="1A365D"/>
-                </a:solidFill>
-              </a:defRPr>
-            </a:pPr>
-            <a:r>
-              <a:t>• 7 modules: monitor, events, contracts, actions, engine, logger, cli (~1,500 LOC)</a:t>
+              <a:defRPr sz="1600">
+                <a:solidFill>
+                  <a:srgbClr val="1A365D"/>
+                </a:solidFill>
+              </a:defRPr>
+            </a:pPr>
+            <a:r>
+              <a:t>• 8 modules: monitor, events, contracts, actions, engine, logger, web, cli</a:t>
             </a:r>
           </a:p>
           <a:p>
@@ -7437,7 +7437,7 @@
               <a:spcAft>
                 <a:spcPts val="800"/>
               </a:spcAft>
-              <a:defRPr sz="1800">
+              <a:defRPr sz="1600">
                 <a:solidFill>
                   <a:srgbClr val="1A365D"/>
                 </a:solidFill>
@@ -7452,7 +7452,7 @@
               <a:spcAft>
                 <a:spcPts val="800"/>
               </a:spcAft>
-              <a:defRPr sz="1800">
+              <a:defRPr sz="1600">
                 <a:solidFill>
                   <a:srgbClr val="1A365D"/>
                 </a:solidFill>
@@ -7467,7 +7467,7 @@
               <a:spcAft>
                 <a:spcPts val="800"/>
               </a:spcAft>
-              <a:defRPr sz="1800">
+              <a:defRPr sz="1600">
                 <a:solidFill>
                   <a:srgbClr val="1A365D"/>
                 </a:solidFill>
@@ -7482,14 +7482,14 @@
               <a:spcAft>
                 <a:spcPts val="800"/>
               </a:spcAft>
-              <a:defRPr sz="1800">
-                <a:solidFill>
-                  <a:srgbClr val="1A365D"/>
-                </a:solidFill>
-              </a:defRPr>
-            </a:pPr>
-            <a:r>
-              <a:t>• Cross-platform: Linux &amp; WSL (full), macOS (no affinity), Windows (no signal suspend)</a:t>
+              <a:defRPr sz="1600">
+                <a:solidFill>
+                  <a:srgbClr val="1A365D"/>
+                </a:solidFill>
+              </a:defRPr>
+            </a:pPr>
+            <a:r>
+              <a:t>• Cross-platform: WSL (full + battery interop bridge), Ubuntu (full), macOS (no affinity),</a:t>
             </a:r>
           </a:p>
           <a:p>
@@ -7497,14 +7497,14 @@
               <a:spcAft>
                 <a:spcPts val="800"/>
               </a:spcAft>
-              <a:defRPr sz="1800">
-                <a:solidFill>
-                  <a:srgbClr val="1A365D"/>
-                </a:solidFill>
-              </a:defRPr>
-            </a:pPr>
-            <a:r>
-              <a:t>• CLI: arc validate | run | simulate | selftest | status</a:t>
+              <a:defRPr sz="1600">
+                <a:solidFill>
+                  <a:srgbClr val="1A365D"/>
+                </a:solidFill>
+              </a:defRPr>
+            </a:pPr>
+            <a:r>
+              <a:t>•   Windows native (no signal suspend; nice ↔ priority classes both ways)</a:t>
             </a:r>
           </a:p>
           <a:p>
@@ -7512,14 +7512,29 @@
               <a:spcAft>
                 <a:spcPts val="800"/>
               </a:spcAft>
-              <a:defRPr sz="1800">
-                <a:solidFill>
-                  <a:srgbClr val="1A365D"/>
-                </a:solidFill>
-              </a:defRPr>
-            </a:pPr>
-            <a:r>
-              <a:t>• 21 unit + integration tests (pytest), 100% pass in both privilege modes</a:t>
+              <a:defRPr sz="1600">
+                <a:solidFill>
+                  <a:srgbClr val="1A365D"/>
+                </a:solidFill>
+              </a:defRPr>
+            </a:pPr>
+            <a:r>
+              <a:t>• CLI: arc validate | run | simulate | demo | web | selftest | status</a:t>
+            </a:r>
+          </a:p>
+          <a:p>
+            <a:pPr>
+              <a:spcAft>
+                <a:spcPts val="800"/>
+              </a:spcAft>
+              <a:defRPr sz="1600">
+                <a:solidFill>
+                  <a:srgbClr val="1A365D"/>
+                </a:solidFill>
+              </a:defRPr>
+            </a:pPr>
+            <a:r>
+              <a:t>• 36 unit + integration tests (pytest), 100% pass in both privilege modes</a:t>
             </a:r>
           </a:p>
         </p:txBody>

</xml_diff>

<commit_message>
Terminal dashboard + closed-loop gap figure
- arc dashboard (rich): full-screen terminal UI - system gauges, contract
  lifecycle badges (IDLE/PENDING/ACTIVE/RESTORING), live event feed,
  CPU sparkline + event-marker history; plain-text fallback without rich
- TRIGGER_OFF now logged when a trigger clears (full lifecycle visibility)
- fig_gap.png: comparison table + closed policy loop (monitor->detect->
  decide->enforce->restore) with existing tools on individual arcs
- PPT: new 'The Gap: Nobody Closes the Loop' slide (19 slides total)
- Report: gap figure as Figure 1 in Literature Survey (figures renumbered)
- DEMO_GUIDE/README updated: dashboard is the demo centerpiece
- 40 tests passing (4 new dashboard/lifecycle tests)
</commit_message>
<xml_diff>
--- a/docs/ARC_Final_Presentation.pptx
+++ b/docs/ARC_Final_Presentation.pptx
@@ -23,6 +23,7 @@
     <p:sldId id="271" r:id="rId22"/>
     <p:sldId id="272" r:id="rId23"/>
     <p:sldId id="273" r:id="rId24"/>
+    <p:sldId id="274" r:id="rId25"/>
   </p:sldIdLst>
   <p:sldSz cx="12191695" cy="6858000" type="screen4x3"/>
   <p:notesSz cx="6858000" cy="9144000"/>
@@ -3290,7 +3291,7 @@
               </a:defRPr>
             </a:pPr>
             <a:r>
-              <a:t>Demo Walkthrough</a:t>
+              <a:t>Implementation</a:t>
             </a:r>
           </a:p>
         </p:txBody>
@@ -3325,7 +3326,7 @@
               </a:defRPr>
             </a:pPr>
             <a:r>
-              <a:t>compile-boost contract + live web dashboard</a:t>
+              <a:t>Portable Python + psutil; one codebase, four platforms</a:t>
             </a:r>
           </a:p>
         </p:txBody>
@@ -3356,14 +3357,14 @@
               <a:spcAft>
                 <a:spcPts val="800"/>
               </a:spcAft>
-              <a:defRPr sz="1700">
-                <a:solidFill>
-                  <a:srgbClr val="1A365D"/>
-                </a:solidFill>
-              </a:defRPr>
-            </a:pPr>
-            <a:r>
-              <a:t>• 1. python3 -m arc web  → live dashboard: gauges, contract states, event feed</a:t>
+              <a:defRPr sz="1600">
+                <a:solidFill>
+                  <a:srgbClr val="1A365D"/>
+                </a:solidFill>
+              </a:defRPr>
+            </a:pPr>
+            <a:r>
+              <a:t>• 8 modules: monitor, events, contracts, actions, engine, logger, web, cli</a:t>
             </a:r>
           </a:p>
           <a:p>
@@ -3371,14 +3372,14 @@
               <a:spcAft>
                 <a:spcPts val="800"/>
               </a:spcAft>
-              <a:defRPr sz="1700">
-                <a:solidFill>
-                  <a:srgbClr val="1A365D"/>
-                </a:solidFill>
-              </a:defRPr>
-            </a:pPr>
-            <a:r>
-              <a:t>• 2. gcc/make appears → debounce 1 s → compiler boosted (nice −5), background deprioritized</a:t>
+              <a:defRPr sz="1600">
+                <a:solidFill>
+                  <a:srgbClr val="1A365D"/>
+                </a:solidFill>
+              </a:defRPr>
+            </a:pPr>
+            <a:r>
+              <a:t>• Concurrency: sampler thread → thread-safe event queue → coordinator (RLock)</a:t>
             </a:r>
           </a:p>
           <a:p>
@@ -3386,14 +3387,14 @@
               <a:spcAft>
                 <a:spcPts val="800"/>
               </a:spcAft>
-              <a:defRPr sz="1700">
-                <a:solidFill>
-                  <a:srgbClr val="1A365D"/>
-                </a:solidFill>
-              </a:defRPr>
-            </a:pPr>
-            <a:r>
-              <a:t>• 3. Build finishes → trigger clears → original nice/affinity restored exactly</a:t>
+              <a:defRPr sz="1600">
+                <a:solidFill>
+                  <a:srgbClr val="1A365D"/>
+                </a:solidFill>
+              </a:defRPr>
+            </a:pPr>
+            <a:r>
+              <a:t>• Capability layer: unsupported actions logged as SKIPPED, never crash</a:t>
             </a:r>
           </a:p>
           <a:p>
@@ -3401,14 +3402,14 @@
               <a:spcAft>
                 <a:spcPts val="800"/>
               </a:spcAft>
-              <a:defRPr sz="1700">
-                <a:solidFill>
-                  <a:srgbClr val="1A365D"/>
-                </a:solidFill>
-              </a:defRPr>
-            </a:pPr>
-            <a:r>
-              <a:t>• 4. Battery drops below 25% → background workloads suspended; plugged in → resumed</a:t>
+              <a:defRPr sz="1600">
+                <a:solidFill>
+                  <a:srgbClr val="1A365D"/>
+                </a:solidFill>
+              </a:defRPr>
+            </a:pPr>
+            <a:r>
+              <a:t>• Privilege handling: nice clamping, cgroup/affinity fallbacks, clear log warnings</a:t>
             </a:r>
           </a:p>
           <a:p>
@@ -3416,29 +3417,59 @@
               <a:spcAft>
                 <a:spcPts val="800"/>
               </a:spcAft>
-              <a:defRPr sz="1700">
-                <a:solidFill>
-                  <a:srgbClr val="1A365D"/>
-                </a:solidFill>
-              </a:defRPr>
-            </a:pPr>
-            <a:r>
-              <a:t>• 5. bash demo/generate_load.sh → CPU pressure → cpu-hot-guard fires on screen</a:t>
-            </a:r>
-          </a:p>
-          <a:p>
-            <a:pPr lvl="1">
+              <a:defRPr sz="1600">
+                <a:solidFill>
+                  <a:srgbClr val="1A365D"/>
+                </a:solidFill>
+              </a:defRPr>
+            </a:pPr>
+            <a:r>
+              <a:t>• Cross-platform: WSL (full + battery interop bridge), Ubuntu (full), macOS (no affinity),</a:t>
+            </a:r>
+          </a:p>
+          <a:p>
+            <a:pPr>
               <a:spcAft>
                 <a:spcPts val="800"/>
               </a:spcAft>
-              <a:defRPr sz="1400">
-                <a:solidFill>
-                  <a:srgbClr val="1A365D"/>
-                </a:solidFill>
-              </a:defRPr>
-            </a:pPr>
-            <a:r>
-              <a:t>– Safe dry-run demo runs on any OS: bash demo/run_demo.sh</a:t>
+              <a:defRPr sz="1600">
+                <a:solidFill>
+                  <a:srgbClr val="1A365D"/>
+                </a:solidFill>
+              </a:defRPr>
+            </a:pPr>
+            <a:r>
+              <a:t>•   Windows native (no signal suspend; nice ↔ priority classes both ways)</a:t>
+            </a:r>
+          </a:p>
+          <a:p>
+            <a:pPr>
+              <a:spcAft>
+                <a:spcPts val="800"/>
+              </a:spcAft>
+              <a:defRPr sz="1600">
+                <a:solidFill>
+                  <a:srgbClr val="1A365D"/>
+                </a:solidFill>
+              </a:defRPr>
+            </a:pPr>
+            <a:r>
+              <a:t>• CLI: arc validate | run | simulate | demo | web | selftest | status</a:t>
+            </a:r>
+          </a:p>
+          <a:p>
+            <a:pPr>
+              <a:spcAft>
+                <a:spcPts val="800"/>
+              </a:spcAft>
+              <a:defRPr sz="1600">
+                <a:solidFill>
+                  <a:srgbClr val="1A365D"/>
+                </a:solidFill>
+              </a:defRPr>
+            </a:pPr>
+            <a:r>
+              <a:t>• 36 unit + integration tests (pytest), 100% pass in both privilege modes</a:t>
             </a:r>
           </a:p>
         </p:txBody>
@@ -3508,7 +3539,7 @@
               </a:defRPr>
             </a:pPr>
             <a:r>
-              <a:t>Results I — Latency &amp; Overhead</a:t>
+              <a:t>Demo Walkthrough</a:t>
             </a:r>
           </a:p>
         </p:txBody>
@@ -3543,253 +3574,120 @@
               </a:defRPr>
             </a:pPr>
             <a:r>
-              <a:t>E1 + E2: tunable response, tiny footprint</a:t>
-            </a:r>
-          </a:p>
-        </p:txBody>
-      </p:sp>
-      <p:pic>
-        <p:nvPicPr>
-          <p:cNvPr id="4" name="Picture 3" descr="e1_latency.png"/>
-          <p:cNvPicPr>
-            <a:picLocks noChangeAspect="1"/>
-          </p:cNvPicPr>
+              <a:t>arc dashboard — the closed loop, live on screen</a:t>
+            </a:r>
+          </a:p>
+        </p:txBody>
+      </p:sp>
+      <p:sp>
+        <p:nvSpPr>
+          <p:cNvPr id="4" name="TextBox 3"/>
+          <p:cNvSpPr txBox="1"/>
           <p:nvPr/>
-        </p:nvPicPr>
-        <p:blipFill>
-          <a:blip r:embed="rId2"/>
-          <a:stretch>
-            <a:fillRect/>
-          </a:stretch>
-        </p:blipFill>
-        <p:spPr>
-          <a:xfrm>
-            <a:off x="457200" y="1417320"/>
-            <a:ext cx="5577840" cy="2826106"/>
+        </p:nvSpPr>
+        <p:spPr>
+          <a:xfrm>
+            <a:off x="548640" y="1554480"/>
+            <a:ext cx="11155680" cy="4846320"/>
           </a:xfrm>
           <a:prstGeom prst="rect">
             <a:avLst/>
           </a:prstGeom>
-        </p:spPr>
-      </p:pic>
-      <p:pic>
-        <p:nvPicPr>
-          <p:cNvPr id="5" name="Picture 4" descr="e2_overhead.png"/>
-          <p:cNvPicPr>
-            <a:picLocks noChangeAspect="1"/>
-          </p:cNvPicPr>
-          <p:nvPr/>
-        </p:nvPicPr>
-        <p:blipFill>
-          <a:blip r:embed="rId3"/>
-          <a:stretch>
-            <a:fillRect/>
-          </a:stretch>
-        </p:blipFill>
-        <p:spPr>
-          <a:xfrm>
-            <a:off x="6263640" y="1417320"/>
-            <a:ext cx="5577840" cy="3346704"/>
-          </a:xfrm>
-          <a:prstGeom prst="rect">
-            <a:avLst/>
-          </a:prstGeom>
-        </p:spPr>
-      </p:pic>
-      <p:sp>
-        <p:nvSpPr>
-          <p:cNvPr id="6" name="Rectangle 5"/>
-          <p:cNvSpPr/>
-          <p:nvPr/>
-        </p:nvSpPr>
-        <p:spPr>
-          <a:xfrm>
-            <a:off x="457200" y="5394960"/>
-            <a:ext cx="3520440" cy="1051560"/>
-          </a:xfrm>
-          <a:prstGeom prst="rect">
-            <a:avLst/>
-          </a:prstGeom>
-          <a:solidFill>
-            <a:srgbClr val="EBF4FF"/>
-          </a:solidFill>
-          <a:ln>
-            <a:solidFill>
-              <a:srgbClr val="2B6CB0"/>
-            </a:solidFill>
-          </a:ln>
-        </p:spPr>
-        <p:style>
-          <a:lnRef idx="1">
-            <a:schemeClr val="accent1"/>
-          </a:lnRef>
-          <a:fillRef idx="3">
-            <a:schemeClr val="accent1"/>
-          </a:fillRef>
-          <a:effectRef idx="2">
-            <a:schemeClr val="accent1"/>
-          </a:effectRef>
-          <a:fontRef idx="minor">
-            <a:schemeClr val="lt1"/>
-          </a:fontRef>
-        </p:style>
-        <p:txBody>
-          <a:bodyPr rtlCol="0" anchor="ctr"/>
-          <a:lstStyle/>
-          <a:p>
-            <a:pPr algn="ctr">
-              <a:defRPr sz="2600" b="1">
-                <a:solidFill>
-                  <a:srgbClr val="2B6CB0"/>
-                </a:solidFill>
-              </a:defRPr>
-            </a:pPr>
-            <a:r>
-              <a:t>202.1 ms</a:t>
-            </a:r>
-          </a:p>
-          <a:p>
-            <a:pPr algn="ctr">
-              <a:defRPr sz="1200">
-                <a:solidFill>
-                  <a:srgbClr val="1A365D"/>
-                </a:solidFill>
-              </a:defRPr>
-            </a:pPr>
-            <a:r>
-              <a:t>trigger→action @ 0.2 s interval</a:t>
-            </a:r>
-          </a:p>
-        </p:txBody>
-      </p:sp>
-      <p:sp>
-        <p:nvSpPr>
-          <p:cNvPr id="7" name="Rectangle 6"/>
-          <p:cNvSpPr/>
-          <p:nvPr/>
-        </p:nvSpPr>
-        <p:spPr>
-          <a:xfrm>
-            <a:off x="4206240" y="5394960"/>
-            <a:ext cx="3520440" cy="1051560"/>
-          </a:xfrm>
-          <a:prstGeom prst="rect">
-            <a:avLst/>
-          </a:prstGeom>
-          <a:solidFill>
-            <a:srgbClr val="EBF4FF"/>
-          </a:solidFill>
-          <a:ln>
-            <a:solidFill>
-              <a:srgbClr val="2B6CB0"/>
-            </a:solidFill>
-          </a:ln>
-        </p:spPr>
-        <p:style>
-          <a:lnRef idx="1">
-            <a:schemeClr val="accent1"/>
-          </a:lnRef>
-          <a:fillRef idx="3">
-            <a:schemeClr val="accent1"/>
-          </a:fillRef>
-          <a:effectRef idx="2">
-            <a:schemeClr val="accent1"/>
-          </a:effectRef>
-          <a:fontRef idx="minor">
-            <a:schemeClr val="lt1"/>
-          </a:fontRef>
-        </p:style>
-        <p:txBody>
-          <a:bodyPr rtlCol="0" anchor="ctr"/>
-          <a:lstStyle/>
-          <a:p>
-            <a:pPr algn="ctr">
-              <a:defRPr sz="2600" b="1">
-                <a:solidFill>
-                  <a:srgbClr val="2B6CB0"/>
-                </a:solidFill>
-              </a:defRPr>
-            </a:pPr>
-            <a:r>
-              <a:t>1.44% / 18.6 MB</a:t>
-            </a:r>
-          </a:p>
-          <a:p>
-            <a:pPr algn="ctr">
-              <a:defRPr sz="1200">
-                <a:solidFill>
-                  <a:srgbClr val="1A365D"/>
-                </a:solidFill>
-              </a:defRPr>
-            </a:pPr>
-            <a:r>
-              <a:t>CPU &amp; RAM @ 1 Hz sampling</a:t>
-            </a:r>
-          </a:p>
-        </p:txBody>
-      </p:sp>
-      <p:sp>
-        <p:nvSpPr>
-          <p:cNvPr id="8" name="Rectangle 7"/>
-          <p:cNvSpPr/>
-          <p:nvPr/>
-        </p:nvSpPr>
-        <p:spPr>
-          <a:xfrm>
-            <a:off x="7955280" y="5394960"/>
-            <a:ext cx="3520440" cy="1051560"/>
-          </a:xfrm>
-          <a:prstGeom prst="rect">
-            <a:avLst/>
-          </a:prstGeom>
-          <a:solidFill>
-            <a:srgbClr val="EBF4FF"/>
-          </a:solidFill>
-          <a:ln>
-            <a:solidFill>
-              <a:srgbClr val="2B6CB0"/>
-            </a:solidFill>
-          </a:ln>
-        </p:spPr>
-        <p:style>
-          <a:lnRef idx="1">
-            <a:schemeClr val="accent1"/>
-          </a:lnRef>
-          <a:fillRef idx="3">
-            <a:schemeClr val="accent1"/>
-          </a:fillRef>
-          <a:effectRef idx="2">
-            <a:schemeClr val="accent1"/>
-          </a:effectRef>
-          <a:fontRef idx="minor">
-            <a:schemeClr val="lt1"/>
-          </a:fontRef>
-        </p:style>
-        <p:txBody>
-          <a:bodyPr rtlCol="0" anchor="ctr"/>
-          <a:lstStyle/>
-          <a:p>
-            <a:pPr algn="ctr">
-              <a:defRPr sz="2600" b="1">
-                <a:solidFill>
-                  <a:srgbClr val="2B6CB0"/>
-                </a:solidFill>
-              </a:defRPr>
-            </a:pPr>
-            <a:r>
-              <a:t>&lt; 6 ms</a:t>
-            </a:r>
-          </a:p>
-          <a:p>
-            <a:pPr algn="ctr">
-              <a:defRPr sz="1200">
-                <a:solidFill>
-                  <a:srgbClr val="1A365D"/>
-                </a:solidFill>
-              </a:defRPr>
-            </a:pPr>
-            <a:r>
-              <a:t>latency jitter (stdev)</a:t>
+          <a:noFill/>
+        </p:spPr>
+        <p:txBody>
+          <a:bodyPr wrap="square">
+            <a:spAutoFit/>
+          </a:bodyPr>
+          <a:lstStyle/>
+          <a:p>
+            <a:pPr>
+              <a:spcAft>
+                <a:spcPts val="800"/>
+              </a:spcAft>
+              <a:defRPr sz="1700">
+                <a:solidFill>
+                  <a:srgbClr val="1A365D"/>
+                </a:solidFill>
+              </a:defRPr>
+            </a:pPr>
+            <a:r>
+              <a:t>• 1. python3 -m arc dashboard → full-screen terminal UI (works on projector/SSH)</a:t>
+            </a:r>
+          </a:p>
+          <a:p>
+            <a:pPr>
+              <a:spcAft>
+                <a:spcPts val="800"/>
+              </a:spcAft>
+              <a:defRPr sz="1700">
+                <a:solidFill>
+                  <a:srgbClr val="1A365D"/>
+                </a:solidFill>
+              </a:defRPr>
+            </a:pPr>
+            <a:r>
+              <a:t>• 2. gcc/make appears → debounce 1 s → compiler boosted (nice −5), background deprioritized</a:t>
+            </a:r>
+          </a:p>
+          <a:p>
+            <a:pPr>
+              <a:spcAft>
+                <a:spcPts val="800"/>
+              </a:spcAft>
+              <a:defRPr sz="1700">
+                <a:solidFill>
+                  <a:srgbClr val="1A365D"/>
+                </a:solidFill>
+              </a:defRPr>
+            </a:pPr>
+            <a:r>
+              <a:t>• 3. Build finishes → TRIGGER_OFF → original nice/affinity restored exactly</a:t>
+            </a:r>
+          </a:p>
+          <a:p>
+            <a:pPr>
+              <a:spcAft>
+                <a:spcPts val="800"/>
+              </a:spcAft>
+              <a:defRPr sz="1700">
+                <a:solidFill>
+                  <a:srgbClr val="1A365D"/>
+                </a:solidFill>
+              </a:defRPr>
+            </a:pPr>
+            <a:r>
+              <a:t>• 4. bash demo/generate_load.sh → CPU pressure → cpu-hot-guard fires with sparkline history</a:t>
+            </a:r>
+          </a:p>
+          <a:p>
+            <a:pPr>
+              <a:spcAft>
+                <a:spcPts val="800"/>
+              </a:spcAft>
+              <a:defRPr sz="1700">
+                <a:solidFill>
+                  <a:srgbClr val="1A365D"/>
+                </a:solidFill>
+              </a:defRPr>
+            </a:pPr>
+            <a:r>
+              <a:t>• 5. Battery below 25% → workloads suspended; plugged in → resumed (WSL bridge included)</a:t>
+            </a:r>
+          </a:p>
+          <a:p>
+            <a:pPr lvl="1">
+              <a:spcAft>
+                <a:spcPts val="800"/>
+              </a:spcAft>
+              <a:defRPr sz="1400">
+                <a:solidFill>
+                  <a:srgbClr val="1A365D"/>
+                </a:solidFill>
+              </a:defRPr>
+            </a:pPr>
+            <a:r>
+              <a:t>– Browser alternative: python3 -m arc web  →  http://localhost:8777</a:t>
             </a:r>
           </a:p>
         </p:txBody>
@@ -3859,7 +3757,7 @@
               </a:defRPr>
             </a:pPr>
             <a:r>
-              <a:t>Results II — Restoration &amp; Enforcement</a:t>
+              <a:t>Results I — Latency &amp; Overhead</a:t>
             </a:r>
           </a:p>
         </p:txBody>
@@ -3894,14 +3792,14 @@
               </a:defRPr>
             </a:pPr>
             <a:r>
-              <a:t>E3 + E4: exact revert, measurable effect</a:t>
+              <a:t>E1 + E2: tunable response, tiny footprint</a:t>
             </a:r>
           </a:p>
         </p:txBody>
       </p:sp>
       <p:pic>
         <p:nvPicPr>
-          <p:cNvPr id="4" name="Picture 3" descr="e4_nice.png"/>
+          <p:cNvPr id="4" name="Picture 3" descr="e1_latency.png"/>
           <p:cNvPicPr>
             <a:picLocks noChangeAspect="1"/>
           </p:cNvPicPr>
@@ -3916,111 +3814,37 @@
         <p:spPr>
           <a:xfrm>
             <a:off x="457200" y="1417320"/>
-            <a:ext cx="6583680" cy="3848921"/>
+            <a:ext cx="5577840" cy="2826106"/>
           </a:xfrm>
           <a:prstGeom prst="rect">
             <a:avLst/>
           </a:prstGeom>
         </p:spPr>
       </p:pic>
-      <p:sp>
-        <p:nvSpPr>
-          <p:cNvPr id="5" name="TextBox 4"/>
-          <p:cNvSpPr txBox="1"/>
+      <p:pic>
+        <p:nvPicPr>
+          <p:cNvPr id="5" name="Picture 4" descr="e2_overhead.png"/>
+          <p:cNvPicPr>
+            <a:picLocks noChangeAspect="1"/>
+          </p:cNvPicPr>
           <p:nvPr/>
-        </p:nvSpPr>
-        <p:spPr>
-          <a:xfrm>
-            <a:off x="7223760" y="1554480"/>
-            <a:ext cx="4572000" cy="4846320"/>
+        </p:nvPicPr>
+        <p:blipFill>
+          <a:blip r:embed="rId3"/>
+          <a:stretch>
+            <a:fillRect/>
+          </a:stretch>
+        </p:blipFill>
+        <p:spPr>
+          <a:xfrm>
+            <a:off x="6263640" y="1417320"/>
+            <a:ext cx="5577840" cy="3346704"/>
           </a:xfrm>
           <a:prstGeom prst="rect">
             <a:avLst/>
           </a:prstGeom>
-          <a:noFill/>
-        </p:spPr>
-        <p:txBody>
-          <a:bodyPr wrap="square">
-            <a:spAutoFit/>
-          </a:bodyPr>
-          <a:lstStyle/>
-          <a:p>
-            <a:pPr>
-              <a:spcAft>
-                <a:spcPts val="800"/>
-              </a:spcAft>
-              <a:defRPr sz="1500">
-                <a:solidFill>
-                  <a:srgbClr val="1A365D"/>
-                </a:solidFill>
-              </a:defRPr>
-            </a:pPr>
-            <a:r>
-              <a:t>• E3: 40/40 exact restorations (100%)</a:t>
-            </a:r>
-          </a:p>
-          <a:p>
-            <a:pPr>
-              <a:spcAft>
-                <a:spcPts val="800"/>
-              </a:spcAft>
-              <a:defRPr sz="1500">
-                <a:solidFill>
-                  <a:srgbClr val="1A365D"/>
-                </a:solidFill>
-              </a:defRPr>
-            </a:pPr>
-            <a:r>
-              <a:t>• Priority + affinity both revert bit-exact</a:t>
-            </a:r>
-          </a:p>
-          <a:p>
-            <a:pPr>
-              <a:spcAft>
-                <a:spcPts val="800"/>
-              </a:spcAft>
-              <a:defRPr sz="1500">
-                <a:solidFill>
-                  <a:srgbClr val="1A365D"/>
-                </a:solidFill>
-              </a:defRPr>
-            </a:pPr>
-            <a:r>
-              <a:t>• E4: protected workload 67% → 99.6% of a core</a:t>
-            </a:r>
-          </a:p>
-          <a:p>
-            <a:pPr>
-              <a:spcAft>
-                <a:spcPts val="800"/>
-              </a:spcAft>
-              <a:defRPr sz="1500">
-                <a:solidFill>
-                  <a:srgbClr val="1A365D"/>
-                </a:solidFill>
-              </a:defRPr>
-            </a:pPr>
-            <a:r>
-              <a:t>• Deprioritized workload drops to 13.9%</a:t>
-            </a:r>
-          </a:p>
-          <a:p>
-            <a:pPr>
-              <a:spcAft>
-                <a:spcPts val="800"/>
-              </a:spcAft>
-              <a:defRPr sz="1500">
-                <a:solidFill>
-                  <a:srgbClr val="1A365D"/>
-                </a:solidFill>
-              </a:defRPr>
-            </a:pPr>
-            <a:r>
-              <a:t>• Actions translate directly into scheduler behavior</a:t>
-            </a:r>
-          </a:p>
-        </p:txBody>
-      </p:sp>
+        </p:spPr>
+      </p:pic>
       <p:sp>
         <p:nvSpPr>
           <p:cNvPr id="6" name="Rectangle 5"/>
@@ -4029,8 +3853,8 @@
         </p:nvSpPr>
         <p:spPr>
           <a:xfrm>
-            <a:off x="457200" y="5623560"/>
-            <a:ext cx="5394960" cy="1051560"/>
+            <a:off x="457200" y="5394960"/>
+            <a:ext cx="3520440" cy="1051560"/>
           </a:xfrm>
           <a:prstGeom prst="rect">
             <a:avLst/>
@@ -4070,7 +3894,7 @@
               </a:defRPr>
             </a:pPr>
             <a:r>
-              <a:t>100.0%</a:t>
+              <a:t>202.1 ms</a:t>
             </a:r>
           </a:p>
           <a:p>
@@ -4082,7 +3906,7 @@
               </a:defRPr>
             </a:pPr>
             <a:r>
-              <a:t>exact restorations</a:t>
+              <a:t>trigger→action @ 0.2 s interval</a:t>
             </a:r>
           </a:p>
         </p:txBody>
@@ -4095,8 +3919,8 @@
         </p:nvSpPr>
         <p:spPr>
           <a:xfrm>
-            <a:off x="6080760" y="5623560"/>
-            <a:ext cx="5394960" cy="1051560"/>
+            <a:off x="4206240" y="5394960"/>
+            <a:ext cx="3520440" cy="1051560"/>
           </a:xfrm>
           <a:prstGeom prst="rect">
             <a:avLst/>
@@ -4136,7 +3960,7 @@
               </a:defRPr>
             </a:pPr>
             <a:r>
-              <a:t>67% → 99.6%</a:t>
+              <a:t>1.44% / 18.6 MB</a:t>
             </a:r>
           </a:p>
           <a:p>
@@ -4148,7 +3972,73 @@
               </a:defRPr>
             </a:pPr>
             <a:r>
-              <a:t>CPU share when protected</a:t>
+              <a:t>CPU &amp; RAM @ 1 Hz sampling</a:t>
+            </a:r>
+          </a:p>
+        </p:txBody>
+      </p:sp>
+      <p:sp>
+        <p:nvSpPr>
+          <p:cNvPr id="8" name="Rectangle 7"/>
+          <p:cNvSpPr/>
+          <p:nvPr/>
+        </p:nvSpPr>
+        <p:spPr>
+          <a:xfrm>
+            <a:off x="7955280" y="5394960"/>
+            <a:ext cx="3520440" cy="1051560"/>
+          </a:xfrm>
+          <a:prstGeom prst="rect">
+            <a:avLst/>
+          </a:prstGeom>
+          <a:solidFill>
+            <a:srgbClr val="EBF4FF"/>
+          </a:solidFill>
+          <a:ln>
+            <a:solidFill>
+              <a:srgbClr val="2B6CB0"/>
+            </a:solidFill>
+          </a:ln>
+        </p:spPr>
+        <p:style>
+          <a:lnRef idx="1">
+            <a:schemeClr val="accent1"/>
+          </a:lnRef>
+          <a:fillRef idx="3">
+            <a:schemeClr val="accent1"/>
+          </a:fillRef>
+          <a:effectRef idx="2">
+            <a:schemeClr val="accent1"/>
+          </a:effectRef>
+          <a:fontRef idx="minor">
+            <a:schemeClr val="lt1"/>
+          </a:fontRef>
+        </p:style>
+        <p:txBody>
+          <a:bodyPr rtlCol="0" anchor="ctr"/>
+          <a:lstStyle/>
+          <a:p>
+            <a:pPr algn="ctr">
+              <a:defRPr sz="2600" b="1">
+                <a:solidFill>
+                  <a:srgbClr val="2B6CB0"/>
+                </a:solidFill>
+              </a:defRPr>
+            </a:pPr>
+            <a:r>
+              <a:t>&lt; 6 ms</a:t>
+            </a:r>
+          </a:p>
+          <a:p>
+            <a:pPr algn="ctr">
+              <a:defRPr sz="1200">
+                <a:solidFill>
+                  <a:srgbClr val="1A365D"/>
+                </a:solidFill>
+              </a:defRPr>
+            </a:pPr>
+            <a:r>
+              <a:t>latency jitter (stdev)</a:t>
             </a:r>
           </a:p>
         </p:txBody>
@@ -4218,7 +4108,7 @@
               </a:defRPr>
             </a:pPr>
             <a:r>
-              <a:t>Results III — Live Lifecycle &amp; Memory Guard</a:t>
+              <a:t>Results II — Restoration &amp; Enforcement</a:t>
             </a:r>
           </a:p>
         </p:txBody>
@@ -4253,14 +4143,14 @@
               </a:defRPr>
             </a:pPr>
             <a:r>
-              <a:t>E5 + E6: complete condition→restoration loop</a:t>
+              <a:t>E3 + E4: exact revert, measurable effect</a:t>
             </a:r>
           </a:p>
         </p:txBody>
       </p:sp>
       <p:pic>
         <p:nvPicPr>
-          <p:cNvPr id="4" name="Picture 3" descr="e5_lifecycle.png"/>
+          <p:cNvPr id="4" name="Picture 3" descr="e4_nice.png"/>
           <p:cNvPicPr>
             <a:picLocks noChangeAspect="1"/>
           </p:cNvPicPr>
@@ -4275,7 +4165,7 @@
         <p:spPr>
           <a:xfrm>
             <a:off x="457200" y="1417320"/>
-            <a:ext cx="5760720" cy="2304288"/>
+            <a:ext cx="6583680" cy="3848921"/>
           </a:xfrm>
           <a:prstGeom prst="rect">
             <a:avLst/>
@@ -4290,8 +4180,8 @@
         </p:nvSpPr>
         <p:spPr>
           <a:xfrm>
-            <a:off x="6492240" y="1554480"/>
-            <a:ext cx="5303520" cy="4846320"/>
+            <a:off x="7223760" y="1554480"/>
+            <a:ext cx="4572000" cy="4846320"/>
           </a:xfrm>
           <a:prstGeom prst="rect">
             <a:avLst/>
@@ -4315,7 +4205,7 @@
               </a:defRPr>
             </a:pPr>
             <a:r>
-              <a:t>• E5: trigger→action 304.3 ms (live processes)</a:t>
+              <a:t>• E3: 40/40 exact restorations (100%)</a:t>
             </a:r>
           </a:p>
           <a:p>
@@ -4330,7 +4220,7 @@
               </a:defRPr>
             </a:pPr>
             <a:r>
-              <a:t>• E5: background nice restored exactly</a:t>
+              <a:t>• Priority + affinity both revert bit-exact</a:t>
             </a:r>
           </a:p>
           <a:p>
@@ -4345,7 +4235,7 @@
               </a:defRPr>
             </a:pPr>
             <a:r>
-              <a:t>• E6: memory 25%→70.0% under 900 MB load</a:t>
+              <a:t>• E4: protected workload 67% → 99.6% of a core</a:t>
             </a:r>
           </a:p>
           <a:p>
@@ -4360,7 +4250,22 @@
               </a:defRPr>
             </a:pPr>
             <a:r>
-              <a:t>• E6: contract triggered, hog nice→10, restored after clearance</a:t>
+              <a:t>• Deprioritized workload drops to 13.9%</a:t>
+            </a:r>
+          </a:p>
+          <a:p>
+            <a:pPr>
+              <a:spcAft>
+                <a:spcPts val="800"/>
+              </a:spcAft>
+              <a:defRPr sz="1500">
+                <a:solidFill>
+                  <a:srgbClr val="1A365D"/>
+                </a:solidFill>
+              </a:defRPr>
+            </a:pPr>
+            <a:r>
+              <a:t>• Actions translate directly into scheduler behavior</a:t>
             </a:r>
           </a:p>
         </p:txBody>
@@ -4374,7 +4279,7 @@
         <p:spPr>
           <a:xfrm>
             <a:off x="457200" y="5623560"/>
-            <a:ext cx="3520440" cy="1051560"/>
+            <a:ext cx="5394960" cy="1051560"/>
           </a:xfrm>
           <a:prstGeom prst="rect">
             <a:avLst/>
@@ -4414,7 +4319,7 @@
               </a:defRPr>
             </a:pPr>
             <a:r>
-              <a:t>304.3 ms</a:t>
+              <a:t>100.0%</a:t>
             </a:r>
           </a:p>
           <a:p>
@@ -4426,7 +4331,7 @@
               </a:defRPr>
             </a:pPr>
             <a:r>
-              <a:t>live trigger→action</a:t>
+              <a:t>exact restorations</a:t>
             </a:r>
           </a:p>
         </p:txBody>
@@ -4439,8 +4344,8 @@
         </p:nvSpPr>
         <p:spPr>
           <a:xfrm>
-            <a:off x="4206240" y="5623560"/>
-            <a:ext cx="3520440" cy="1051560"/>
+            <a:off x="6080760" y="5623560"/>
+            <a:ext cx="5394960" cy="1051560"/>
           </a:xfrm>
           <a:prstGeom prst="rect">
             <a:avLst/>
@@ -4480,7 +4385,7 @@
               </a:defRPr>
             </a:pPr>
             <a:r>
-              <a:t>40/40</a:t>
+              <a:t>67% → 99.6%</a:t>
             </a:r>
           </a:p>
           <a:p>
@@ -4492,73 +4397,7 @@
               </a:defRPr>
             </a:pPr>
             <a:r>
-              <a:t>exact restores</a:t>
-            </a:r>
-          </a:p>
-        </p:txBody>
-      </p:sp>
-      <p:sp>
-        <p:nvSpPr>
-          <p:cNvPr id="8" name="Rectangle 7"/>
-          <p:cNvSpPr/>
-          <p:nvPr/>
-        </p:nvSpPr>
-        <p:spPr>
-          <a:xfrm>
-            <a:off x="7955280" y="5623560"/>
-            <a:ext cx="3520440" cy="1051560"/>
-          </a:xfrm>
-          <a:prstGeom prst="rect">
-            <a:avLst/>
-          </a:prstGeom>
-          <a:solidFill>
-            <a:srgbClr val="EBF4FF"/>
-          </a:solidFill>
-          <a:ln>
-            <a:solidFill>
-              <a:srgbClr val="2B6CB0"/>
-            </a:solidFill>
-          </a:ln>
-        </p:spPr>
-        <p:style>
-          <a:lnRef idx="1">
-            <a:schemeClr val="accent1"/>
-          </a:lnRef>
-          <a:fillRef idx="3">
-            <a:schemeClr val="accent1"/>
-          </a:fillRef>
-          <a:effectRef idx="2">
-            <a:schemeClr val="accent1"/>
-          </a:effectRef>
-          <a:fontRef idx="minor">
-            <a:schemeClr val="lt1"/>
-          </a:fontRef>
-        </p:style>
-        <p:txBody>
-          <a:bodyPr rtlCol="0" anchor="ctr"/>
-          <a:lstStyle/>
-          <a:p>
-            <a:pPr algn="ctr">
-              <a:defRPr sz="2600" b="1">
-                <a:solidFill>
-                  <a:srgbClr val="2B6CB0"/>
-                </a:solidFill>
-              </a:defRPr>
-            </a:pPr>
-            <a:r>
-              <a:t>YES</a:t>
-            </a:r>
-          </a:p>
-          <a:p>
-            <a:pPr algn="ctr">
-              <a:defRPr sz="1200">
-                <a:solidFill>
-                  <a:srgbClr val="1A365D"/>
-                </a:solidFill>
-              </a:defRPr>
-            </a:pPr>
-            <a:r>
-              <a:t>memory guard lifecycle</a:t>
+              <a:t>CPU share when protected</a:t>
             </a:r>
           </a:p>
         </p:txBody>
@@ -4628,7 +4467,7 @@
               </a:defRPr>
             </a:pPr>
             <a:r>
-              <a:t>Discussion</a:t>
+              <a:t>Results III — Live Lifecycle &amp; Memory Guard</a:t>
             </a:r>
           </a:p>
         </p:txBody>
@@ -4663,21 +4502,45 @@
               </a:defRPr>
             </a:pPr>
             <a:r>
-              <a:t>What the numbers mean</a:t>
-            </a:r>
-          </a:p>
-        </p:txBody>
-      </p:sp>
-      <p:sp>
-        <p:nvSpPr>
-          <p:cNvPr id="4" name="TextBox 3"/>
+              <a:t>E5 + E6: complete condition→restoration loop</a:t>
+            </a:r>
+          </a:p>
+        </p:txBody>
+      </p:sp>
+      <p:pic>
+        <p:nvPicPr>
+          <p:cNvPr id="4" name="Picture 3" descr="e5_lifecycle.png"/>
+          <p:cNvPicPr>
+            <a:picLocks noChangeAspect="1"/>
+          </p:cNvPicPr>
+          <p:nvPr/>
+        </p:nvPicPr>
+        <p:blipFill>
+          <a:blip r:embed="rId2"/>
+          <a:stretch>
+            <a:fillRect/>
+          </a:stretch>
+        </p:blipFill>
+        <p:spPr>
+          <a:xfrm>
+            <a:off x="457200" y="1417320"/>
+            <a:ext cx="5760720" cy="2304288"/>
+          </a:xfrm>
+          <a:prstGeom prst="rect">
+            <a:avLst/>
+          </a:prstGeom>
+        </p:spPr>
+      </p:pic>
+      <p:sp>
+        <p:nvSpPr>
+          <p:cNvPr id="5" name="TextBox 4"/>
           <p:cNvSpPr txBox="1"/>
           <p:nvPr/>
         </p:nvSpPr>
         <p:spPr>
           <a:xfrm>
-            <a:off x="548640" y="1554480"/>
-            <a:ext cx="11155680" cy="4846320"/>
+            <a:off x="6492240" y="1554480"/>
+            <a:ext cx="5303520" cy="4846320"/>
           </a:xfrm>
           <a:prstGeom prst="rect">
             <a:avLst/>
@@ -4694,14 +4557,14 @@
               <a:spcAft>
                 <a:spcPts val="800"/>
               </a:spcAft>
-              <a:defRPr sz="1800">
-                <a:solidFill>
-                  <a:srgbClr val="1A365D"/>
-                </a:solidFill>
-              </a:defRPr>
-            </a:pPr>
-            <a:r>
-              <a:t>• Latency is deterministic and tunable: it equals the sampling interval operators choose</a:t>
+              <a:defRPr sz="1500">
+                <a:solidFill>
+                  <a:srgbClr val="1A365D"/>
+                </a:solidFill>
+              </a:defRPr>
+            </a:pPr>
+            <a:r>
+              <a:t>• E5: trigger→action 304.3 ms (live processes)</a:t>
             </a:r>
           </a:p>
           <a:p>
@@ -4709,14 +4572,14 @@
               <a:spcAft>
                 <a:spcPts val="800"/>
               </a:spcAft>
-              <a:defRPr sz="1800">
-                <a:solidFill>
-                  <a:srgbClr val="1A365D"/>
-                </a:solidFill>
-              </a:defRPr>
-            </a:pPr>
-            <a:r>
-              <a:t>• Overhead low enough for always-on background operation</a:t>
+              <a:defRPr sz="1500">
+                <a:solidFill>
+                  <a:srgbClr val="1A365D"/>
+                </a:solidFill>
+              </a:defRPr>
+            </a:pPr>
+            <a:r>
+              <a:t>• E5: background nice restored exactly</a:t>
             </a:r>
           </a:p>
           <a:p>
@@ -4724,14 +4587,14 @@
               <a:spcAft>
                 <a:spcPts val="800"/>
               </a:spcAft>
-              <a:defRPr sz="1800">
-                <a:solidFill>
-                  <a:srgbClr val="1A365D"/>
-                </a:solidFill>
-              </a:defRPr>
-            </a:pPr>
-            <a:r>
-              <a:t>• Restoration solves the biggest flaw of ad-hoc scripting: policies that never get undone</a:t>
+              <a:defRPr sz="1500">
+                <a:solidFill>
+                  <a:srgbClr val="1A365D"/>
+                </a:solidFill>
+              </a:defRPr>
+            </a:pPr>
+            <a:r>
+              <a:t>• E6: memory 25%→70.0% under 900 MB load</a:t>
             </a:r>
           </a:p>
           <a:p>
@@ -4739,29 +4602,212 @@
               <a:spcAft>
                 <a:spcPts val="800"/>
               </a:spcAft>
-              <a:defRPr sz="1800">
-                <a:solidFill>
-                  <a:srgbClr val="1A365D"/>
-                </a:solidFill>
-              </a:defRPr>
-            </a:pPr>
-            <a:r>
-              <a:t>• Limitations: sampling-based detection (not kernel events); privilege needed to raise priority on POSIX</a:t>
-            </a:r>
-          </a:p>
-          <a:p>
-            <a:pPr>
-              <a:spcAft>
-                <a:spcPts val="800"/>
-              </a:spcAft>
-              <a:defRPr sz="1800">
-                <a:solidFill>
-                  <a:srgbClr val="1A365D"/>
-                </a:solidFill>
-              </a:defRPr>
-            </a:pPr>
-            <a:r>
-              <a:t>• Works uniformly across Linux, WSL, macOS, Windows with graceful degradation</a:t>
+              <a:defRPr sz="1500">
+                <a:solidFill>
+                  <a:srgbClr val="1A365D"/>
+                </a:solidFill>
+              </a:defRPr>
+            </a:pPr>
+            <a:r>
+              <a:t>• E6: contract triggered, hog nice→10, restored after clearance</a:t>
+            </a:r>
+          </a:p>
+        </p:txBody>
+      </p:sp>
+      <p:sp>
+        <p:nvSpPr>
+          <p:cNvPr id="6" name="Rectangle 5"/>
+          <p:cNvSpPr/>
+          <p:nvPr/>
+        </p:nvSpPr>
+        <p:spPr>
+          <a:xfrm>
+            <a:off x="457200" y="5623560"/>
+            <a:ext cx="3520440" cy="1051560"/>
+          </a:xfrm>
+          <a:prstGeom prst="rect">
+            <a:avLst/>
+          </a:prstGeom>
+          <a:solidFill>
+            <a:srgbClr val="EBF4FF"/>
+          </a:solidFill>
+          <a:ln>
+            <a:solidFill>
+              <a:srgbClr val="2B6CB0"/>
+            </a:solidFill>
+          </a:ln>
+        </p:spPr>
+        <p:style>
+          <a:lnRef idx="1">
+            <a:schemeClr val="accent1"/>
+          </a:lnRef>
+          <a:fillRef idx="3">
+            <a:schemeClr val="accent1"/>
+          </a:fillRef>
+          <a:effectRef idx="2">
+            <a:schemeClr val="accent1"/>
+          </a:effectRef>
+          <a:fontRef idx="minor">
+            <a:schemeClr val="lt1"/>
+          </a:fontRef>
+        </p:style>
+        <p:txBody>
+          <a:bodyPr rtlCol="0" anchor="ctr"/>
+          <a:lstStyle/>
+          <a:p>
+            <a:pPr algn="ctr">
+              <a:defRPr sz="2600" b="1">
+                <a:solidFill>
+                  <a:srgbClr val="2B6CB0"/>
+                </a:solidFill>
+              </a:defRPr>
+            </a:pPr>
+            <a:r>
+              <a:t>304.3 ms</a:t>
+            </a:r>
+          </a:p>
+          <a:p>
+            <a:pPr algn="ctr">
+              <a:defRPr sz="1200">
+                <a:solidFill>
+                  <a:srgbClr val="1A365D"/>
+                </a:solidFill>
+              </a:defRPr>
+            </a:pPr>
+            <a:r>
+              <a:t>live trigger→action</a:t>
+            </a:r>
+          </a:p>
+        </p:txBody>
+      </p:sp>
+      <p:sp>
+        <p:nvSpPr>
+          <p:cNvPr id="7" name="Rectangle 6"/>
+          <p:cNvSpPr/>
+          <p:nvPr/>
+        </p:nvSpPr>
+        <p:spPr>
+          <a:xfrm>
+            <a:off x="4206240" y="5623560"/>
+            <a:ext cx="3520440" cy="1051560"/>
+          </a:xfrm>
+          <a:prstGeom prst="rect">
+            <a:avLst/>
+          </a:prstGeom>
+          <a:solidFill>
+            <a:srgbClr val="EBF4FF"/>
+          </a:solidFill>
+          <a:ln>
+            <a:solidFill>
+              <a:srgbClr val="2B6CB0"/>
+            </a:solidFill>
+          </a:ln>
+        </p:spPr>
+        <p:style>
+          <a:lnRef idx="1">
+            <a:schemeClr val="accent1"/>
+          </a:lnRef>
+          <a:fillRef idx="3">
+            <a:schemeClr val="accent1"/>
+          </a:fillRef>
+          <a:effectRef idx="2">
+            <a:schemeClr val="accent1"/>
+          </a:effectRef>
+          <a:fontRef idx="minor">
+            <a:schemeClr val="lt1"/>
+          </a:fontRef>
+        </p:style>
+        <p:txBody>
+          <a:bodyPr rtlCol="0" anchor="ctr"/>
+          <a:lstStyle/>
+          <a:p>
+            <a:pPr algn="ctr">
+              <a:defRPr sz="2600" b="1">
+                <a:solidFill>
+                  <a:srgbClr val="2B6CB0"/>
+                </a:solidFill>
+              </a:defRPr>
+            </a:pPr>
+            <a:r>
+              <a:t>40/40</a:t>
+            </a:r>
+          </a:p>
+          <a:p>
+            <a:pPr algn="ctr">
+              <a:defRPr sz="1200">
+                <a:solidFill>
+                  <a:srgbClr val="1A365D"/>
+                </a:solidFill>
+              </a:defRPr>
+            </a:pPr>
+            <a:r>
+              <a:t>exact restores</a:t>
+            </a:r>
+          </a:p>
+        </p:txBody>
+      </p:sp>
+      <p:sp>
+        <p:nvSpPr>
+          <p:cNvPr id="8" name="Rectangle 7"/>
+          <p:cNvSpPr/>
+          <p:nvPr/>
+        </p:nvSpPr>
+        <p:spPr>
+          <a:xfrm>
+            <a:off x="7955280" y="5623560"/>
+            <a:ext cx="3520440" cy="1051560"/>
+          </a:xfrm>
+          <a:prstGeom prst="rect">
+            <a:avLst/>
+          </a:prstGeom>
+          <a:solidFill>
+            <a:srgbClr val="EBF4FF"/>
+          </a:solidFill>
+          <a:ln>
+            <a:solidFill>
+              <a:srgbClr val="2B6CB0"/>
+            </a:solidFill>
+          </a:ln>
+        </p:spPr>
+        <p:style>
+          <a:lnRef idx="1">
+            <a:schemeClr val="accent1"/>
+          </a:lnRef>
+          <a:fillRef idx="3">
+            <a:schemeClr val="accent1"/>
+          </a:fillRef>
+          <a:effectRef idx="2">
+            <a:schemeClr val="accent1"/>
+          </a:effectRef>
+          <a:fontRef idx="minor">
+            <a:schemeClr val="lt1"/>
+          </a:fontRef>
+        </p:style>
+        <p:txBody>
+          <a:bodyPr rtlCol="0" anchor="ctr"/>
+          <a:lstStyle/>
+          <a:p>
+            <a:pPr algn="ctr">
+              <a:defRPr sz="2600" b="1">
+                <a:solidFill>
+                  <a:srgbClr val="2B6CB0"/>
+                </a:solidFill>
+              </a:defRPr>
+            </a:pPr>
+            <a:r>
+              <a:t>YES</a:t>
+            </a:r>
+          </a:p>
+          <a:p>
+            <a:pPr algn="ctr">
+              <a:defRPr sz="1200">
+                <a:solidFill>
+                  <a:srgbClr val="1A365D"/>
+                </a:solidFill>
+              </a:defRPr>
+            </a:pPr>
+            <a:r>
+              <a:t>memory guard lifecycle</a:t>
             </a:r>
           </a:p>
         </p:txBody>
@@ -4831,35 +4877,144 @@
               </a:defRPr>
             </a:pPr>
             <a:r>
-              <a:t>Results at a Glance</a:t>
-            </a:r>
-          </a:p>
-        </p:txBody>
-      </p:sp>
-      <p:pic>
-        <p:nvPicPr>
-          <p:cNvPr id="3" name="Picture 2" descr="fig_kpi.png"/>
-          <p:cNvPicPr>
-            <a:picLocks noChangeAspect="1"/>
-          </p:cNvPicPr>
+              <a:t>Discussion</a:t>
+            </a:r>
+          </a:p>
+        </p:txBody>
+      </p:sp>
+      <p:sp>
+        <p:nvSpPr>
+          <p:cNvPr id="3" name="TextBox 2"/>
+          <p:cNvSpPr txBox="1"/>
           <p:nvPr/>
-        </p:nvPicPr>
-        <p:blipFill>
-          <a:blip r:embed="rId2"/>
-          <a:stretch>
-            <a:fillRect/>
-          </a:stretch>
-        </p:blipFill>
-        <p:spPr>
-          <a:xfrm>
-            <a:off x="1051560" y="1463040"/>
-            <a:ext cx="10058400" cy="4224528"/>
+        </p:nvSpPr>
+        <p:spPr>
+          <a:xfrm>
+            <a:off x="457200" y="1024128"/>
+            <a:ext cx="11338560" cy="411480"/>
           </a:xfrm>
           <a:prstGeom prst="rect">
             <a:avLst/>
           </a:prstGeom>
-        </p:spPr>
-      </p:pic>
+          <a:noFill/>
+        </p:spPr>
+        <p:txBody>
+          <a:bodyPr wrap="none">
+            <a:spAutoFit/>
+          </a:bodyPr>
+          <a:lstStyle/>
+          <a:p>
+            <a:pPr>
+              <a:defRPr sz="1600" i="1">
+                <a:solidFill>
+                  <a:srgbClr val="2B6CB0"/>
+                </a:solidFill>
+              </a:defRPr>
+            </a:pPr>
+            <a:r>
+              <a:t>What the numbers mean</a:t>
+            </a:r>
+          </a:p>
+        </p:txBody>
+      </p:sp>
+      <p:sp>
+        <p:nvSpPr>
+          <p:cNvPr id="4" name="TextBox 3"/>
+          <p:cNvSpPr txBox="1"/>
+          <p:nvPr/>
+        </p:nvSpPr>
+        <p:spPr>
+          <a:xfrm>
+            <a:off x="548640" y="1554480"/>
+            <a:ext cx="11155680" cy="4846320"/>
+          </a:xfrm>
+          <a:prstGeom prst="rect">
+            <a:avLst/>
+          </a:prstGeom>
+          <a:noFill/>
+        </p:spPr>
+        <p:txBody>
+          <a:bodyPr wrap="square">
+            <a:spAutoFit/>
+          </a:bodyPr>
+          <a:lstStyle/>
+          <a:p>
+            <a:pPr>
+              <a:spcAft>
+                <a:spcPts val="800"/>
+              </a:spcAft>
+              <a:defRPr sz="1800">
+                <a:solidFill>
+                  <a:srgbClr val="1A365D"/>
+                </a:solidFill>
+              </a:defRPr>
+            </a:pPr>
+            <a:r>
+              <a:t>• Latency is deterministic and tunable: it equals the sampling interval operators choose</a:t>
+            </a:r>
+          </a:p>
+          <a:p>
+            <a:pPr>
+              <a:spcAft>
+                <a:spcPts val="800"/>
+              </a:spcAft>
+              <a:defRPr sz="1800">
+                <a:solidFill>
+                  <a:srgbClr val="1A365D"/>
+                </a:solidFill>
+              </a:defRPr>
+            </a:pPr>
+            <a:r>
+              <a:t>• Overhead low enough for always-on background operation</a:t>
+            </a:r>
+          </a:p>
+          <a:p>
+            <a:pPr>
+              <a:spcAft>
+                <a:spcPts val="800"/>
+              </a:spcAft>
+              <a:defRPr sz="1800">
+                <a:solidFill>
+                  <a:srgbClr val="1A365D"/>
+                </a:solidFill>
+              </a:defRPr>
+            </a:pPr>
+            <a:r>
+              <a:t>• Restoration solves the biggest flaw of ad-hoc scripting: policies that never get undone</a:t>
+            </a:r>
+          </a:p>
+          <a:p>
+            <a:pPr>
+              <a:spcAft>
+                <a:spcPts val="800"/>
+              </a:spcAft>
+              <a:defRPr sz="1800">
+                <a:solidFill>
+                  <a:srgbClr val="1A365D"/>
+                </a:solidFill>
+              </a:defRPr>
+            </a:pPr>
+            <a:r>
+              <a:t>• Limitations: sampling-based detection (not kernel events); privilege needed to raise priority on POSIX</a:t>
+            </a:r>
+          </a:p>
+          <a:p>
+            <a:pPr>
+              <a:spcAft>
+                <a:spcPts val="800"/>
+              </a:spcAft>
+              <a:defRPr sz="1800">
+                <a:solidFill>
+                  <a:srgbClr val="1A365D"/>
+                </a:solidFill>
+              </a:defRPr>
+            </a:pPr>
+            <a:r>
+              <a:t>• Works uniformly across Linux, WSL, macOS, Windows with graceful degradation</a:t>
+            </a:r>
+          </a:p>
+        </p:txBody>
+      </p:sp>
     </p:spTree>
   </p:cSld>
   <p:clrMapOvr>
@@ -4925,109 +5080,35 @@
               </a:defRPr>
             </a:pPr>
             <a:r>
-              <a:t>Conclusion &amp; Future Work</a:t>
-            </a:r>
-          </a:p>
-        </p:txBody>
-      </p:sp>
-      <p:sp>
-        <p:nvSpPr>
-          <p:cNvPr id="3" name="TextBox 2"/>
-          <p:cNvSpPr txBox="1"/>
+              <a:t>Results at a Glance</a:t>
+            </a:r>
+          </a:p>
+        </p:txBody>
+      </p:sp>
+      <p:pic>
+        <p:nvPicPr>
+          <p:cNvPr id="3" name="Picture 2" descr="fig_kpi.png"/>
+          <p:cNvPicPr>
+            <a:picLocks noChangeAspect="1"/>
+          </p:cNvPicPr>
           <p:nvPr/>
-        </p:nvSpPr>
-        <p:spPr>
-          <a:xfrm>
-            <a:off x="548640" y="1554480"/>
-            <a:ext cx="11155680" cy="4846320"/>
+        </p:nvPicPr>
+        <p:blipFill>
+          <a:blip r:embed="rId2"/>
+          <a:stretch>
+            <a:fillRect/>
+          </a:stretch>
+        </p:blipFill>
+        <p:spPr>
+          <a:xfrm>
+            <a:off x="1051560" y="1463040"/>
+            <a:ext cx="10058400" cy="4224528"/>
           </a:xfrm>
           <a:prstGeom prst="rect">
             <a:avLst/>
           </a:prstGeom>
-          <a:noFill/>
-        </p:spPr>
-        <p:txBody>
-          <a:bodyPr wrap="square">
-            <a:spAutoFit/>
-          </a:bodyPr>
-          <a:lstStyle/>
-          <a:p>
-            <a:pPr>
-              <a:spcAft>
-                <a:spcPts val="800"/>
-              </a:spcAft>
-              <a:defRPr sz="1800">
-                <a:solidFill>
-                  <a:srgbClr val="1A365D"/>
-                </a:solidFill>
-              </a:defRPr>
-            </a:pPr>
-            <a:r>
-              <a:t>• ARC = monitoring + event detection + contracts + dynamic enforcement + restoration in one layer</a:t>
-            </a:r>
-          </a:p>
-          <a:p>
-            <a:pPr>
-              <a:spcAft>
-                <a:spcPts val="800"/>
-              </a:spcAft>
-              <a:defRPr sz="1800">
-                <a:solidFill>
-                  <a:srgbClr val="1A365D"/>
-                </a:solidFill>
-              </a:defRPr>
-            </a:pPr>
-            <a:r>
-              <a:t>• Demonstrates OS concepts in a real system: scheduling, affinity, signals, cgroups, concurrency, protection</a:t>
-            </a:r>
-          </a:p>
-          <a:p>
-            <a:pPr>
-              <a:spcAft>
-                <a:spcPts val="800"/>
-              </a:spcAft>
-              <a:defRPr sz="1800">
-                <a:solidFill>
-                  <a:srgbClr val="1A365D"/>
-                </a:solidFill>
-              </a:defRPr>
-            </a:pPr>
-            <a:r>
-              <a:t>• Delivers full Review-3 scope: implementation, experimentation, performance evaluation</a:t>
-            </a:r>
-          </a:p>
-          <a:p>
-            <a:pPr>
-              <a:spcAft>
-                <a:spcPts val="800"/>
-              </a:spcAft>
-              <a:defRPr sz="1800">
-                <a:solidFill>
-                  <a:srgbClr val="1A365D"/>
-                </a:solidFill>
-              </a:defRPr>
-            </a:pPr>
-            <a:r>
-              <a:t>• Live web dashboard (arc web) for real-time demonstration of policy decisions</a:t>
-            </a:r>
-          </a:p>
-          <a:p>
-            <a:pPr>
-              <a:spcAft>
-                <a:spcPts val="800"/>
-              </a:spcAft>
-              <a:defRPr sz="1800">
-                <a:solidFill>
-                  <a:srgbClr val="1A365D"/>
-                </a:solidFill>
-              </a:defRPr>
-            </a:pPr>
-            <a:r>
-              <a:t>• Future: eBPF/proc-connector events, I/O + memory.high controls, contract conflict resolution, full management GUI, systemd packaging, publication extension</a:t>
-            </a:r>
-          </a:p>
-        </p:txBody>
-      </p:sp>
+        </p:spPr>
+      </p:pic>
     </p:spTree>
   </p:cSld>
   <p:clrMapOvr>
@@ -5093,7 +5174,7 @@
               </a:defRPr>
             </a:pPr>
             <a:r>
-              <a:t>References</a:t>
+              <a:t>Conclusion &amp; Future Work</a:t>
             </a:r>
           </a:p>
         </p:txBody>
@@ -5124,14 +5205,14 @@
               <a:spcAft>
                 <a:spcPts val="800"/>
               </a:spcAft>
-              <a:defRPr sz="1500">
-                <a:solidFill>
-                  <a:srgbClr val="1A365D"/>
-                </a:solidFill>
-              </a:defRPr>
-            </a:pPr>
-            <a:r>
-              <a:t>• [1] Linux Kernel Documentation, "Control Group v2." kernel.org</a:t>
+              <a:defRPr sz="1800">
+                <a:solidFill>
+                  <a:srgbClr val="1A365D"/>
+                </a:solidFill>
+              </a:defRPr>
+            </a:pPr>
+            <a:r>
+              <a:t>• ARC = monitoring + event detection + contracts + dynamic enforcement + restoration in one layer</a:t>
             </a:r>
           </a:p>
           <a:p>
@@ -5139,14 +5220,14 @@
               <a:spcAft>
                 <a:spcPts val="800"/>
               </a:spcAft>
-              <a:defRPr sz="1500">
-                <a:solidFill>
-                  <a:srgbClr val="1A365D"/>
-                </a:solidFill>
-              </a:defRPr>
-            </a:pPr>
-            <a:r>
-              <a:t>• [2] Linux Kernel Documentation, "The /proc Filesystem." kernel.org</a:t>
+              <a:defRPr sz="1800">
+                <a:solidFill>
+                  <a:srgbClr val="1A365D"/>
+                </a:solidFill>
+              </a:defRPr>
+            </a:pPr>
+            <a:r>
+              <a:t>• Demonstrates OS concepts in a real system: scheduling, affinity, signals, cgroups, concurrency, protection</a:t>
             </a:r>
           </a:p>
           <a:p>
@@ -5154,14 +5235,14 @@
               <a:spcAft>
                 <a:spcPts val="800"/>
               </a:spcAft>
-              <a:defRPr sz="1500">
-                <a:solidFill>
-                  <a:srgbClr val="1A365D"/>
-                </a:solidFill>
-              </a:defRPr>
-            </a:pPr>
-            <a:r>
-              <a:t>• [3] Ananicy-cpp: An Auto Nice Daemon. github.com/CachyOS/ananicy-cpp</a:t>
+              <a:defRPr sz="1800">
+                <a:solidFill>
+                  <a:srgbClr val="1A365D"/>
+                </a:solidFill>
+              </a:defRPr>
+            </a:pPr>
+            <a:r>
+              <a:t>• Delivers full Review-3 scope: implementation, experimentation, performance evaluation</a:t>
             </a:r>
           </a:p>
           <a:p>
@@ -5169,14 +5250,14 @@
               <a:spcAft>
                 <a:spcPts val="800"/>
               </a:spcAft>
-              <a:defRPr sz="1500">
-                <a:solidFill>
-                  <a:srgbClr val="1A365D"/>
-                </a:solidFill>
-              </a:defRPr>
-            </a:pPr>
-            <a:r>
-              <a:t>• [4] systemd-oomd.service. freedesktop.org</a:t>
+              <a:defRPr sz="1800">
+                <a:solidFill>
+                  <a:srgbClr val="1A365D"/>
+                </a:solidFill>
+              </a:defRPr>
+            </a:pPr>
+            <a:r>
+              <a:t>• Live web dashboard (arc web) for real-time demonstration of policy decisions</a:t>
             </a:r>
           </a:p>
           <a:p>
@@ -5184,74 +5265,14 @@
               <a:spcAft>
                 <a:spcPts val="800"/>
               </a:spcAft>
-              <a:defRPr sz="1500">
-                <a:solidFill>
-                  <a:srgbClr val="1A365D"/>
-                </a:solidFill>
-              </a:defRPr>
-            </a:pPr>
-            <a:r>
-              <a:t>• [5] TuneD Project Documentation. tuned-project.org</a:t>
-            </a:r>
-          </a:p>
-          <a:p>
-            <a:pPr>
-              <a:spcAft>
-                <a:spcPts val="800"/>
-              </a:spcAft>
-              <a:defRPr sz="1500">
-                <a:solidFill>
-                  <a:srgbClr val="1A365D"/>
-                </a:solidFill>
-              </a:defRPr>
-            </a:pPr>
-            <a:r>
-              <a:t>• [6] S. Goodarzy et al., "SmartOS: Towards Automated Learning and User-Adaptive Resource Allocation in Operating Systems," APSys 2021</a:t>
-            </a:r>
-          </a:p>
-          <a:p>
-            <a:pPr>
-              <a:spcAft>
-                <a:spcPts val="800"/>
-              </a:spcAft>
-              <a:defRPr sz="1500">
-                <a:solidFill>
-                  <a:srgbClr val="1A365D"/>
-                </a:solidFill>
-              </a:defRPr>
-            </a:pPr>
-            <a:r>
-              <a:t>• [7] M. Kerrisk, "sched_setaffinity(2)," Linux man-pages</a:t>
-            </a:r>
-          </a:p>
-          <a:p>
-            <a:pPr>
-              <a:spcAft>
-                <a:spcPts val="800"/>
-              </a:spcAft>
-              <a:defRPr sz="1500">
-                <a:solidFill>
-                  <a:srgbClr val="1A365D"/>
-                </a:solidFill>
-              </a:defRPr>
-            </a:pPr>
-            <a:r>
-              <a:t>• [8] W. M. Stevens, S. A. Rago, Advanced Programming in the UNIX Environment, 3rd ed., 2013</a:t>
-            </a:r>
-          </a:p>
-          <a:p>
-            <a:pPr>
-              <a:spcAft>
-                <a:spcPts val="800"/>
-              </a:spcAft>
-              <a:defRPr sz="1500">
-                <a:solidFill>
-                  <a:srgbClr val="1A365D"/>
-                </a:solidFill>
-              </a:defRPr>
-            </a:pPr>
-            <a:r>
-              <a:t>• [9] psutil documentation. psutil.readthedocs.io</a:t>
+              <a:defRPr sz="1800">
+                <a:solidFill>
+                  <a:srgbClr val="1A365D"/>
+                </a:solidFill>
+              </a:defRPr>
+            </a:pPr>
+            <a:r>
+              <a:t>• Future: eBPF/proc-connector events, I/O + memory.high controls, contract conflict resolution, full management GUI, systemd packaging, publication extension</a:t>
             </a:r>
           </a:p>
         </p:txBody>
@@ -5265,6 +5286,234 @@
 </file>
 
 <file path=ppt/slides/slide18.xml><?xml version="1.0" encoding="utf-8"?>
+<p:sld xmlns:a="http://schemas.openxmlformats.org/drawingml/2006/main" xmlns:p="http://schemas.openxmlformats.org/presentationml/2006/main" xmlns:r="http://schemas.openxmlformats.org/officeDocument/2006/relationships">
+  <p:cSld>
+    <p:spTree>
+      <p:nvGrpSpPr>
+        <p:cNvPr id="1" name=""/>
+        <p:cNvGrpSpPr/>
+        <p:nvPr/>
+      </p:nvGrpSpPr>
+      <p:grpSpPr/>
+      <p:sp>
+        <p:nvSpPr>
+          <p:cNvPr id="2" name="Rectangle 1"/>
+          <p:cNvSpPr/>
+          <p:nvPr/>
+        </p:nvSpPr>
+        <p:spPr>
+          <a:xfrm>
+            <a:off x="0" y="0"/>
+            <a:ext cx="12191695" cy="960120"/>
+          </a:xfrm>
+          <a:prstGeom prst="rect">
+            <a:avLst/>
+          </a:prstGeom>
+          <a:solidFill>
+            <a:srgbClr val="1A365D"/>
+          </a:solidFill>
+          <a:ln>
+            <a:noFill/>
+          </a:ln>
+        </p:spPr>
+        <p:style>
+          <a:lnRef idx="1">
+            <a:schemeClr val="accent1"/>
+          </a:lnRef>
+          <a:fillRef idx="3">
+            <a:schemeClr val="accent1"/>
+          </a:fillRef>
+          <a:effectRef idx="2">
+            <a:schemeClr val="accent1"/>
+          </a:effectRef>
+          <a:fontRef idx="minor">
+            <a:schemeClr val="lt1"/>
+          </a:fontRef>
+        </p:style>
+        <p:txBody>
+          <a:bodyPr rtlCol="0" anchor="ctr" lIns="411480"/>
+          <a:lstStyle/>
+          <a:p>
+            <a:pPr algn="l">
+              <a:defRPr sz="3000" b="1">
+                <a:solidFill>
+                  <a:srgbClr val="FFFFFF"/>
+                </a:solidFill>
+              </a:defRPr>
+            </a:pPr>
+            <a:r>
+              <a:t>References</a:t>
+            </a:r>
+          </a:p>
+        </p:txBody>
+      </p:sp>
+      <p:sp>
+        <p:nvSpPr>
+          <p:cNvPr id="3" name="TextBox 2"/>
+          <p:cNvSpPr txBox="1"/>
+          <p:nvPr/>
+        </p:nvSpPr>
+        <p:spPr>
+          <a:xfrm>
+            <a:off x="548640" y="1554480"/>
+            <a:ext cx="11155680" cy="4846320"/>
+          </a:xfrm>
+          <a:prstGeom prst="rect">
+            <a:avLst/>
+          </a:prstGeom>
+          <a:noFill/>
+        </p:spPr>
+        <p:txBody>
+          <a:bodyPr wrap="square">
+            <a:spAutoFit/>
+          </a:bodyPr>
+          <a:lstStyle/>
+          <a:p>
+            <a:pPr>
+              <a:spcAft>
+                <a:spcPts val="800"/>
+              </a:spcAft>
+              <a:defRPr sz="1500">
+                <a:solidFill>
+                  <a:srgbClr val="1A365D"/>
+                </a:solidFill>
+              </a:defRPr>
+            </a:pPr>
+            <a:r>
+              <a:t>• [1] Linux Kernel Documentation, "Control Group v2." kernel.org</a:t>
+            </a:r>
+          </a:p>
+          <a:p>
+            <a:pPr>
+              <a:spcAft>
+                <a:spcPts val="800"/>
+              </a:spcAft>
+              <a:defRPr sz="1500">
+                <a:solidFill>
+                  <a:srgbClr val="1A365D"/>
+                </a:solidFill>
+              </a:defRPr>
+            </a:pPr>
+            <a:r>
+              <a:t>• [2] Linux Kernel Documentation, "The /proc Filesystem." kernel.org</a:t>
+            </a:r>
+          </a:p>
+          <a:p>
+            <a:pPr>
+              <a:spcAft>
+                <a:spcPts val="800"/>
+              </a:spcAft>
+              <a:defRPr sz="1500">
+                <a:solidFill>
+                  <a:srgbClr val="1A365D"/>
+                </a:solidFill>
+              </a:defRPr>
+            </a:pPr>
+            <a:r>
+              <a:t>• [3] Ananicy-cpp: An Auto Nice Daemon. github.com/CachyOS/ananicy-cpp</a:t>
+            </a:r>
+          </a:p>
+          <a:p>
+            <a:pPr>
+              <a:spcAft>
+                <a:spcPts val="800"/>
+              </a:spcAft>
+              <a:defRPr sz="1500">
+                <a:solidFill>
+                  <a:srgbClr val="1A365D"/>
+                </a:solidFill>
+              </a:defRPr>
+            </a:pPr>
+            <a:r>
+              <a:t>• [4] systemd-oomd.service. freedesktop.org</a:t>
+            </a:r>
+          </a:p>
+          <a:p>
+            <a:pPr>
+              <a:spcAft>
+                <a:spcPts val="800"/>
+              </a:spcAft>
+              <a:defRPr sz="1500">
+                <a:solidFill>
+                  <a:srgbClr val="1A365D"/>
+                </a:solidFill>
+              </a:defRPr>
+            </a:pPr>
+            <a:r>
+              <a:t>• [5] TuneD Project Documentation. tuned-project.org</a:t>
+            </a:r>
+          </a:p>
+          <a:p>
+            <a:pPr>
+              <a:spcAft>
+                <a:spcPts val="800"/>
+              </a:spcAft>
+              <a:defRPr sz="1500">
+                <a:solidFill>
+                  <a:srgbClr val="1A365D"/>
+                </a:solidFill>
+              </a:defRPr>
+            </a:pPr>
+            <a:r>
+              <a:t>• [6] S. Goodarzy et al., "SmartOS: Towards Automated Learning and User-Adaptive Resource Allocation in Operating Systems," APSys 2021</a:t>
+            </a:r>
+          </a:p>
+          <a:p>
+            <a:pPr>
+              <a:spcAft>
+                <a:spcPts val="800"/>
+              </a:spcAft>
+              <a:defRPr sz="1500">
+                <a:solidFill>
+                  <a:srgbClr val="1A365D"/>
+                </a:solidFill>
+              </a:defRPr>
+            </a:pPr>
+            <a:r>
+              <a:t>• [7] M. Kerrisk, "sched_setaffinity(2)," Linux man-pages</a:t>
+            </a:r>
+          </a:p>
+          <a:p>
+            <a:pPr>
+              <a:spcAft>
+                <a:spcPts val="800"/>
+              </a:spcAft>
+              <a:defRPr sz="1500">
+                <a:solidFill>
+                  <a:srgbClr val="1A365D"/>
+                </a:solidFill>
+              </a:defRPr>
+            </a:pPr>
+            <a:r>
+              <a:t>• [8] W. M. Stevens, S. A. Rago, Advanced Programming in the UNIX Environment, 3rd ed., 2013</a:t>
+            </a:r>
+          </a:p>
+          <a:p>
+            <a:pPr>
+              <a:spcAft>
+                <a:spcPts val="800"/>
+              </a:spcAft>
+              <a:defRPr sz="1500">
+                <a:solidFill>
+                  <a:srgbClr val="1A365D"/>
+                </a:solidFill>
+              </a:defRPr>
+            </a:pPr>
+            <a:r>
+              <a:t>• [9] psutil documentation. psutil.readthedocs.io</a:t>
+            </a:r>
+          </a:p>
+        </p:txBody>
+      </p:sp>
+    </p:spTree>
+  </p:cSld>
+  <p:clrMapOvr>
+    <a:masterClrMapping/>
+  </p:clrMapOvr>
+</p:sld>
+</file>
+
+<file path=ppt/slides/slide19.xml><?xml version="1.0" encoding="utf-8"?>
 <p:sld xmlns:a="http://schemas.openxmlformats.org/drawingml/2006/main" xmlns:p="http://schemas.openxmlformats.org/presentationml/2006/main" xmlns:r="http://schemas.openxmlformats.org/officeDocument/2006/relationships">
   <p:cSld>
     <p:spTree>
@@ -6681,7 +6930,7 @@
               </a:defRPr>
             </a:pPr>
             <a:r>
-              <a:t>Architecture</a:t>
+              <a:t>The Gap: Nobody Closes the Loop</a:t>
             </a:r>
           </a:p>
         </p:txBody>
@@ -6716,14 +6965,14 @@
               </a:defRPr>
             </a:pPr>
             <a:r>
-              <a:t>Modular pipeline — every stage extensible in isolation</a:t>
+              <a:t>Existing tools each cover a slice — a contract spans the whole cycle</a:t>
             </a:r>
           </a:p>
         </p:txBody>
       </p:sp>
       <p:pic>
         <p:nvPicPr>
-          <p:cNvPr id="4" name="Picture 3" descr="fig_architecture.png"/>
+          <p:cNvPr id="4" name="Picture 3" descr="fig_gap.png"/>
           <p:cNvPicPr>
             <a:picLocks noChangeAspect="1"/>
           </p:cNvPicPr>
@@ -6737,8 +6986,8 @@
         </p:blipFill>
         <p:spPr>
           <a:xfrm>
-            <a:off x="1097280" y="1371600"/>
-            <a:ext cx="10058400" cy="5025982"/>
+            <a:off x="640080" y="1417320"/>
+            <a:ext cx="10972800" cy="4710672"/>
           </a:xfrm>
           <a:prstGeom prst="rect">
             <a:avLst/>
@@ -6810,7 +7059,7 @@
               </a:defRPr>
             </a:pPr>
             <a:r>
-              <a:t>Contract Model</a:t>
+              <a:t>Architecture</a:t>
             </a:r>
           </a:p>
         </p:txBody>
@@ -6845,270 +7094,35 @@
               </a:defRPr>
             </a:pPr>
             <a:r>
-              <a:t>Declarative YAML: trigger → actions → restoration</a:t>
-            </a:r>
-          </a:p>
-        </p:txBody>
-      </p:sp>
-      <p:sp>
-        <p:nvSpPr>
-          <p:cNvPr id="4" name="TextBox 3"/>
-          <p:cNvSpPr txBox="1"/>
+              <a:t>Modular pipeline — every stage extensible in isolation</a:t>
+            </a:r>
+          </a:p>
+        </p:txBody>
+      </p:sp>
+      <p:pic>
+        <p:nvPicPr>
+          <p:cNvPr id="4" name="Picture 3" descr="fig_architecture.png"/>
+          <p:cNvPicPr>
+            <a:picLocks noChangeAspect="1"/>
+          </p:cNvPicPr>
           <p:nvPr/>
-        </p:nvSpPr>
-        <p:spPr>
-          <a:xfrm>
-            <a:off x="640080" y="1554480"/>
-            <a:ext cx="6766560" cy="4206240"/>
+        </p:nvPicPr>
+        <p:blipFill>
+          <a:blip r:embed="rId2"/>
+          <a:stretch>
+            <a:fillRect/>
+          </a:stretch>
+        </p:blipFill>
+        <p:spPr>
+          <a:xfrm>
+            <a:off x="1097280" y="1371600"/>
+            <a:ext cx="10058400" cy="5025982"/>
           </a:xfrm>
           <a:prstGeom prst="rect">
             <a:avLst/>
           </a:prstGeom>
-          <a:noFill/>
-        </p:spPr>
-        <p:txBody>
-          <a:bodyPr wrap="square">
-            <a:spAutoFit/>
-          </a:bodyPr>
-          <a:lstStyle/>
-          <a:p>
-            <a:pPr>
-              <a:defRPr sz="1400">
-                <a:solidFill>
-                  <a:srgbClr val="1A365D"/>
-                </a:solidFill>
-                <a:latin typeface="Consolas"/>
-              </a:defRPr>
-            </a:pPr>
-            <a:r>
-              <a:t>contracts:</a:t>
-            </a:r>
-          </a:p>
-          <a:p>
-            <a:pPr>
-              <a:defRPr sz="1400">
-                <a:solidFill>
-                  <a:srgbClr val="1A365D"/>
-                </a:solidFill>
-                <a:latin typeface="Consolas"/>
-              </a:defRPr>
-            </a:pPr>
-            <a:r>
-              <a:t>  - name: compile-boost</a:t>
-            </a:r>
-          </a:p>
-          <a:p>
-            <a:pPr>
-              <a:defRPr sz="1400">
-                <a:solidFill>
-                  <a:srgbClr val="1A365D"/>
-                </a:solidFill>
-                <a:latin typeface="Consolas"/>
-              </a:defRPr>
-            </a:pPr>
-            <a:r>
-              <a:t>    trigger:</a:t>
-            </a:r>
-          </a:p>
-          <a:p>
-            <a:pPr>
-              <a:defRPr sz="1400">
-                <a:solidFill>
-                  <a:srgbClr val="1A365D"/>
-                </a:solidFill>
-                <a:latin typeface="Consolas"/>
-              </a:defRPr>
-            </a:pPr>
-            <a:r>
-              <a:t>      type: process_appears          # also: metric_threshold, battery_below</a:t>
-            </a:r>
-          </a:p>
-          <a:p>
-            <a:pPr>
-              <a:defRPr sz="1400">
-                <a:solidFill>
-                  <a:srgbClr val="1A365D"/>
-                </a:solidFill>
-                <a:latin typeface="Consolas"/>
-              </a:defRPr>
-            </a:pPr>
-            <a:r>
-              <a:t>      match: "gcc|cc1plus|make"</a:t>
-            </a:r>
-          </a:p>
-          <a:p>
-            <a:pPr>
-              <a:defRPr sz="1400">
-                <a:solidFill>
-                  <a:srgbClr val="1A365D"/>
-                </a:solidFill>
-                <a:latin typeface="Consolas"/>
-              </a:defRPr>
-            </a:pPr>
-            <a:r>
-              <a:t>      debounce_sec: 1.0</a:t>
-            </a:r>
-          </a:p>
-          <a:p>
-            <a:pPr>
-              <a:defRPr sz="1400">
-                <a:solidFill>
-                  <a:srgbClr val="1A365D"/>
-                </a:solidFill>
-                <a:latin typeface="Consolas"/>
-              </a:defRPr>
-            </a:pPr>
-            <a:r>
-              <a:t>    actions:</a:t>
-            </a:r>
-          </a:p>
-          <a:p>
-            <a:pPr>
-              <a:defRPr sz="1400">
-                <a:solidFill>
-                  <a:srgbClr val="1A365D"/>
-                </a:solidFill>
-                <a:latin typeface="Consolas"/>
-              </a:defRPr>
-            </a:pPr>
-            <a:r>
-              <a:t>      - {type: set_nice,  target: {match: "cc1plus"}, nice: -5}</a:t>
-            </a:r>
-          </a:p>
-          <a:p>
-            <a:pPr>
-              <a:defRPr sz="1400">
-                <a:solidFill>
-                  <a:srgbClr val="1A365D"/>
-                </a:solidFill>
-                <a:latin typeface="Consolas"/>
-              </a:defRPr>
-            </a:pPr>
-            <a:r>
-              <a:t>      - {type: set_nice,  target: {match: "chromium"}, nice: 10}</a:t>
-            </a:r>
-          </a:p>
-          <a:p>
-            <a:pPr>
-              <a:defRPr sz="1400">
-                <a:solidFill>
-                  <a:srgbClr val="1A365D"/>
-                </a:solidFill>
-                <a:latin typeface="Consolas"/>
-              </a:defRPr>
-            </a:pPr>
-            <a:r>
-              <a:t>    restore: {mode: on_trigger_clear}   # also: after_timeout, never</a:t>
-            </a:r>
-          </a:p>
-          <a:p>
-            <a:pPr>
-              <a:defRPr sz="1400">
-                <a:solidFill>
-                  <a:srgbClr val="1A365D"/>
-                </a:solidFill>
-                <a:latin typeface="Consolas"/>
-              </a:defRPr>
-            </a:pPr>
-            <a:r>
-              <a:t>    cooldown_sec: 5.0</a:t>
-            </a:r>
-          </a:p>
-          <a:p>
-            <a:pPr>
-              <a:defRPr sz="1400">
-                <a:solidFill>
-                  <a:srgbClr val="1A365D"/>
-                </a:solidFill>
-                <a:latin typeface="Consolas"/>
-              </a:defRPr>
-            </a:pPr>
-          </a:p>
-        </p:txBody>
-      </p:sp>
-      <p:sp>
-        <p:nvSpPr>
-          <p:cNvPr id="5" name="TextBox 4"/>
-          <p:cNvSpPr txBox="1"/>
-          <p:nvPr/>
-        </p:nvSpPr>
-        <p:spPr>
-          <a:xfrm>
-            <a:off x="7589520" y="1645920"/>
-            <a:ext cx="4206240" cy="4846320"/>
-          </a:xfrm>
-          <a:prstGeom prst="rect">
-            <a:avLst/>
-          </a:prstGeom>
-          <a:noFill/>
-        </p:spPr>
-        <p:txBody>
-          <a:bodyPr wrap="square">
-            <a:spAutoFit/>
-          </a:bodyPr>
-          <a:lstStyle/>
-          <a:p>
-            <a:pPr>
-              <a:spcAft>
-                <a:spcPts val="800"/>
-              </a:spcAft>
-              <a:defRPr sz="1500">
-                <a:solidFill>
-                  <a:srgbClr val="1A365D"/>
-                </a:solidFill>
-              </a:defRPr>
-            </a:pPr>
-            <a:r>
-              <a:t>• Triggers: process events, CPU/mem/load thresholds, battery</a:t>
-            </a:r>
-          </a:p>
-          <a:p>
-            <a:pPr>
-              <a:spcAft>
-                <a:spcPts val="800"/>
-              </a:spcAft>
-              <a:defRPr sz="1500">
-                <a:solidFill>
-                  <a:srgbClr val="1A365D"/>
-                </a:solidFill>
-              </a:defRPr>
-            </a:pPr>
-            <a:r>
-              <a:t>• Actions: nice, affinity, suspend/resume, cgroup limits, log</a:t>
-            </a:r>
-          </a:p>
-          <a:p>
-            <a:pPr>
-              <a:spcAft>
-                <a:spcPts val="800"/>
-              </a:spcAft>
-              <a:defRPr sz="1500">
-                <a:solidFill>
-                  <a:srgbClr val="1A365D"/>
-                </a:solidFill>
-              </a:defRPr>
-            </a:pPr>
-            <a:r>
-              <a:t>• Restoration: exact revert of every snapshot</a:t>
-            </a:r>
-          </a:p>
-          <a:p>
-            <a:pPr>
-              <a:spcAft>
-                <a:spcPts val="800"/>
-              </a:spcAft>
-              <a:defRPr sz="1500">
-                <a:solidFill>
-                  <a:srgbClr val="1A365D"/>
-                </a:solidFill>
-              </a:defRPr>
-            </a:pPr>
-            <a:r>
-              <a:t>• PID + create-time check defeats PID reuse</a:t>
-            </a:r>
-          </a:p>
-        </p:txBody>
-      </p:sp>
+        </p:spPr>
+      </p:pic>
     </p:spTree>
   </p:cSld>
   <p:clrMapOvr>
@@ -7174,7 +7188,7 @@
               </a:defRPr>
             </a:pPr>
             <a:r>
-              <a:t>Contract Lifecycle</a:t>
+              <a:t>Contract Model</a:t>
             </a:r>
           </a:p>
         </p:txBody>
@@ -7209,45 +7223,21 @@
               </a:defRPr>
             </a:pPr>
             <a:r>
-              <a:t>Every contract is a small state machine</a:t>
-            </a:r>
-          </a:p>
-        </p:txBody>
-      </p:sp>
-      <p:pic>
-        <p:nvPicPr>
-          <p:cNvPr id="4" name="Picture 3" descr="fig_state_machine.png"/>
-          <p:cNvPicPr>
-            <a:picLocks noChangeAspect="1"/>
-          </p:cNvPicPr>
-          <p:nvPr/>
-        </p:nvPicPr>
-        <p:blipFill>
-          <a:blip r:embed="rId2"/>
-          <a:stretch>
-            <a:fillRect/>
-          </a:stretch>
-        </p:blipFill>
-        <p:spPr>
-          <a:xfrm>
-            <a:off x="1463040" y="1463040"/>
-            <a:ext cx="9326880" cy="3470467"/>
-          </a:xfrm>
-          <a:prstGeom prst="rect">
-            <a:avLst/>
-          </a:prstGeom>
-        </p:spPr>
-      </p:pic>
-      <p:sp>
-        <p:nvSpPr>
-          <p:cNvPr id="5" name="TextBox 4"/>
+              <a:t>Declarative YAML: trigger → actions → restoration</a:t>
+            </a:r>
+          </a:p>
+        </p:txBody>
+      </p:sp>
+      <p:sp>
+        <p:nvSpPr>
+          <p:cNvPr id="4" name="TextBox 3"/>
           <p:cNvSpPr txBox="1"/>
           <p:nvPr/>
         </p:nvSpPr>
         <p:spPr>
           <a:xfrm>
-            <a:off x="548640" y="5212080"/>
-            <a:ext cx="11155680" cy="4846320"/>
+            <a:off x="640080" y="1554480"/>
+            <a:ext cx="6766560" cy="4206240"/>
           </a:xfrm>
           <a:prstGeom prst="rect">
             <a:avLst/>
@@ -7261,17 +7251,193 @@
           <a:lstStyle/>
           <a:p>
             <a:pPr>
+              <a:defRPr sz="1400">
+                <a:solidFill>
+                  <a:srgbClr val="1A365D"/>
+                </a:solidFill>
+                <a:latin typeface="Consolas"/>
+              </a:defRPr>
+            </a:pPr>
+            <a:r>
+              <a:t>contracts:</a:t>
+            </a:r>
+          </a:p>
+          <a:p>
+            <a:pPr>
+              <a:defRPr sz="1400">
+                <a:solidFill>
+                  <a:srgbClr val="1A365D"/>
+                </a:solidFill>
+                <a:latin typeface="Consolas"/>
+              </a:defRPr>
+            </a:pPr>
+            <a:r>
+              <a:t>  - name: compile-boost</a:t>
+            </a:r>
+          </a:p>
+          <a:p>
+            <a:pPr>
+              <a:defRPr sz="1400">
+                <a:solidFill>
+                  <a:srgbClr val="1A365D"/>
+                </a:solidFill>
+                <a:latin typeface="Consolas"/>
+              </a:defRPr>
+            </a:pPr>
+            <a:r>
+              <a:t>    trigger:</a:t>
+            </a:r>
+          </a:p>
+          <a:p>
+            <a:pPr>
+              <a:defRPr sz="1400">
+                <a:solidFill>
+                  <a:srgbClr val="1A365D"/>
+                </a:solidFill>
+                <a:latin typeface="Consolas"/>
+              </a:defRPr>
+            </a:pPr>
+            <a:r>
+              <a:t>      type: process_appears          # also: metric_threshold, battery_below</a:t>
+            </a:r>
+          </a:p>
+          <a:p>
+            <a:pPr>
+              <a:defRPr sz="1400">
+                <a:solidFill>
+                  <a:srgbClr val="1A365D"/>
+                </a:solidFill>
+                <a:latin typeface="Consolas"/>
+              </a:defRPr>
+            </a:pPr>
+            <a:r>
+              <a:t>      match: "gcc|cc1plus|make"</a:t>
+            </a:r>
+          </a:p>
+          <a:p>
+            <a:pPr>
+              <a:defRPr sz="1400">
+                <a:solidFill>
+                  <a:srgbClr val="1A365D"/>
+                </a:solidFill>
+                <a:latin typeface="Consolas"/>
+              </a:defRPr>
+            </a:pPr>
+            <a:r>
+              <a:t>      debounce_sec: 1.0</a:t>
+            </a:r>
+          </a:p>
+          <a:p>
+            <a:pPr>
+              <a:defRPr sz="1400">
+                <a:solidFill>
+                  <a:srgbClr val="1A365D"/>
+                </a:solidFill>
+                <a:latin typeface="Consolas"/>
+              </a:defRPr>
+            </a:pPr>
+            <a:r>
+              <a:t>    actions:</a:t>
+            </a:r>
+          </a:p>
+          <a:p>
+            <a:pPr>
+              <a:defRPr sz="1400">
+                <a:solidFill>
+                  <a:srgbClr val="1A365D"/>
+                </a:solidFill>
+                <a:latin typeface="Consolas"/>
+              </a:defRPr>
+            </a:pPr>
+            <a:r>
+              <a:t>      - {type: set_nice,  target: {match: "cc1plus"}, nice: -5}</a:t>
+            </a:r>
+          </a:p>
+          <a:p>
+            <a:pPr>
+              <a:defRPr sz="1400">
+                <a:solidFill>
+                  <a:srgbClr val="1A365D"/>
+                </a:solidFill>
+                <a:latin typeface="Consolas"/>
+              </a:defRPr>
+            </a:pPr>
+            <a:r>
+              <a:t>      - {type: set_nice,  target: {match: "chromium"}, nice: 10}</a:t>
+            </a:r>
+          </a:p>
+          <a:p>
+            <a:pPr>
+              <a:defRPr sz="1400">
+                <a:solidFill>
+                  <a:srgbClr val="1A365D"/>
+                </a:solidFill>
+                <a:latin typeface="Consolas"/>
+              </a:defRPr>
+            </a:pPr>
+            <a:r>
+              <a:t>    restore: {mode: on_trigger_clear}   # also: after_timeout, never</a:t>
+            </a:r>
+          </a:p>
+          <a:p>
+            <a:pPr>
+              <a:defRPr sz="1400">
+                <a:solidFill>
+                  <a:srgbClr val="1A365D"/>
+                </a:solidFill>
+                <a:latin typeface="Consolas"/>
+              </a:defRPr>
+            </a:pPr>
+            <a:r>
+              <a:t>    cooldown_sec: 5.0</a:t>
+            </a:r>
+          </a:p>
+          <a:p>
+            <a:pPr>
+              <a:defRPr sz="1400">
+                <a:solidFill>
+                  <a:srgbClr val="1A365D"/>
+                </a:solidFill>
+                <a:latin typeface="Consolas"/>
+              </a:defRPr>
+            </a:pPr>
+          </a:p>
+        </p:txBody>
+      </p:sp>
+      <p:sp>
+        <p:nvSpPr>
+          <p:cNvPr id="5" name="TextBox 4"/>
+          <p:cNvSpPr txBox="1"/>
+          <p:nvPr/>
+        </p:nvSpPr>
+        <p:spPr>
+          <a:xfrm>
+            <a:off x="7589520" y="1645920"/>
+            <a:ext cx="4206240" cy="4846320"/>
+          </a:xfrm>
+          <a:prstGeom prst="rect">
+            <a:avLst/>
+          </a:prstGeom>
+          <a:noFill/>
+        </p:spPr>
+        <p:txBody>
+          <a:bodyPr wrap="square">
+            <a:spAutoFit/>
+          </a:bodyPr>
+          <a:lstStyle/>
+          <a:p>
+            <a:pPr>
               <a:spcAft>
                 <a:spcPts val="800"/>
               </a:spcAft>
-              <a:defRPr sz="1600">
-                <a:solidFill>
-                  <a:srgbClr val="1A365D"/>
-                </a:solidFill>
-              </a:defRPr>
-            </a:pPr>
-            <a:r>
-              <a:t>• Debounce / hold windows prevent flapping; cooldown prevents re-trigger storms</a:t>
+              <a:defRPr sz="1500">
+                <a:solidFill>
+                  <a:srgbClr val="1A365D"/>
+                </a:solidFill>
+              </a:defRPr>
+            </a:pPr>
+            <a:r>
+              <a:t>• Triggers: process events, CPU/mem/load thresholds, battery</a:t>
             </a:r>
           </a:p>
           <a:p>
@@ -7279,14 +7445,44 @@
               <a:spcAft>
                 <a:spcPts val="800"/>
               </a:spcAft>
-              <a:defRPr sz="1600">
-                <a:solidFill>
-                  <a:srgbClr val="1A365D"/>
-                </a:solidFill>
-              </a:defRPr>
-            </a:pPr>
-            <a:r>
-              <a:t>• Engine shutdown restores all active contracts (no leaked policies)</a:t>
+              <a:defRPr sz="1500">
+                <a:solidFill>
+                  <a:srgbClr val="1A365D"/>
+                </a:solidFill>
+              </a:defRPr>
+            </a:pPr>
+            <a:r>
+              <a:t>• Actions: nice, affinity, suspend/resume, cgroup limits, log</a:t>
+            </a:r>
+          </a:p>
+          <a:p>
+            <a:pPr>
+              <a:spcAft>
+                <a:spcPts val="800"/>
+              </a:spcAft>
+              <a:defRPr sz="1500">
+                <a:solidFill>
+                  <a:srgbClr val="1A365D"/>
+                </a:solidFill>
+              </a:defRPr>
+            </a:pPr>
+            <a:r>
+              <a:t>• Restoration: exact revert of every snapshot</a:t>
+            </a:r>
+          </a:p>
+          <a:p>
+            <a:pPr>
+              <a:spcAft>
+                <a:spcPts val="800"/>
+              </a:spcAft>
+              <a:defRPr sz="1500">
+                <a:solidFill>
+                  <a:srgbClr val="1A365D"/>
+                </a:solidFill>
+              </a:defRPr>
+            </a:pPr>
+            <a:r>
+              <a:t>• PID + create-time check defeats PID reuse</a:t>
             </a:r>
           </a:p>
         </p:txBody>
@@ -7356,7 +7552,7 @@
               </a:defRPr>
             </a:pPr>
             <a:r>
-              <a:t>Implementation</a:t>
+              <a:t>Contract Lifecycle</a:t>
             </a:r>
           </a:p>
         </p:txBody>
@@ -7391,20 +7587,44 @@
               </a:defRPr>
             </a:pPr>
             <a:r>
-              <a:t>Portable Python + psutil; one codebase, four platforms</a:t>
-            </a:r>
-          </a:p>
-        </p:txBody>
-      </p:sp>
-      <p:sp>
-        <p:nvSpPr>
-          <p:cNvPr id="4" name="TextBox 3"/>
+              <a:t>Every contract is a small state machine</a:t>
+            </a:r>
+          </a:p>
+        </p:txBody>
+      </p:sp>
+      <p:pic>
+        <p:nvPicPr>
+          <p:cNvPr id="4" name="Picture 3" descr="fig_state_machine.png"/>
+          <p:cNvPicPr>
+            <a:picLocks noChangeAspect="1"/>
+          </p:cNvPicPr>
+          <p:nvPr/>
+        </p:nvPicPr>
+        <p:blipFill>
+          <a:blip r:embed="rId2"/>
+          <a:stretch>
+            <a:fillRect/>
+          </a:stretch>
+        </p:blipFill>
+        <p:spPr>
+          <a:xfrm>
+            <a:off x="1463040" y="1463040"/>
+            <a:ext cx="9326880" cy="3470467"/>
+          </a:xfrm>
+          <a:prstGeom prst="rect">
+            <a:avLst/>
+          </a:prstGeom>
+        </p:spPr>
+      </p:pic>
+      <p:sp>
+        <p:nvSpPr>
+          <p:cNvPr id="5" name="TextBox 4"/>
           <p:cNvSpPr txBox="1"/>
           <p:nvPr/>
         </p:nvSpPr>
         <p:spPr>
           <a:xfrm>
-            <a:off x="548640" y="1554480"/>
+            <a:off x="548640" y="5212080"/>
             <a:ext cx="11155680" cy="4846320"/>
           </a:xfrm>
           <a:prstGeom prst="rect">
@@ -7429,7 +7649,7 @@
               </a:defRPr>
             </a:pPr>
             <a:r>
-              <a:t>• 8 modules: monitor, events, contracts, actions, engine, logger, web, cli</a:t>
+              <a:t>• Debounce / hold windows prevent flapping; cooldown prevents re-trigger storms</a:t>
             </a:r>
           </a:p>
           <a:p>
@@ -7444,97 +7664,7 @@
               </a:defRPr>
             </a:pPr>
             <a:r>
-              <a:t>• Concurrency: sampler thread → thread-safe event queue → coordinator (RLock)</a:t>
-            </a:r>
-          </a:p>
-          <a:p>
-            <a:pPr>
-              <a:spcAft>
-                <a:spcPts val="800"/>
-              </a:spcAft>
-              <a:defRPr sz="1600">
-                <a:solidFill>
-                  <a:srgbClr val="1A365D"/>
-                </a:solidFill>
-              </a:defRPr>
-            </a:pPr>
-            <a:r>
-              <a:t>• Capability layer: unsupported actions logged as SKIPPED, never crash</a:t>
-            </a:r>
-          </a:p>
-          <a:p>
-            <a:pPr>
-              <a:spcAft>
-                <a:spcPts val="800"/>
-              </a:spcAft>
-              <a:defRPr sz="1600">
-                <a:solidFill>
-                  <a:srgbClr val="1A365D"/>
-                </a:solidFill>
-              </a:defRPr>
-            </a:pPr>
-            <a:r>
-              <a:t>• Privilege handling: nice clamping, cgroup/affinity fallbacks, clear log warnings</a:t>
-            </a:r>
-          </a:p>
-          <a:p>
-            <a:pPr>
-              <a:spcAft>
-                <a:spcPts val="800"/>
-              </a:spcAft>
-              <a:defRPr sz="1600">
-                <a:solidFill>
-                  <a:srgbClr val="1A365D"/>
-                </a:solidFill>
-              </a:defRPr>
-            </a:pPr>
-            <a:r>
-              <a:t>• Cross-platform: WSL (full + battery interop bridge), Ubuntu (full), macOS (no affinity),</a:t>
-            </a:r>
-          </a:p>
-          <a:p>
-            <a:pPr>
-              <a:spcAft>
-                <a:spcPts val="800"/>
-              </a:spcAft>
-              <a:defRPr sz="1600">
-                <a:solidFill>
-                  <a:srgbClr val="1A365D"/>
-                </a:solidFill>
-              </a:defRPr>
-            </a:pPr>
-            <a:r>
-              <a:t>•   Windows native (no signal suspend; nice ↔ priority classes both ways)</a:t>
-            </a:r>
-          </a:p>
-          <a:p>
-            <a:pPr>
-              <a:spcAft>
-                <a:spcPts val="800"/>
-              </a:spcAft>
-              <a:defRPr sz="1600">
-                <a:solidFill>
-                  <a:srgbClr val="1A365D"/>
-                </a:solidFill>
-              </a:defRPr>
-            </a:pPr>
-            <a:r>
-              <a:t>• CLI: arc validate | run | simulate | demo | web | selftest | status</a:t>
-            </a:r>
-          </a:p>
-          <a:p>
-            <a:pPr>
-              <a:spcAft>
-                <a:spcPts val="800"/>
-              </a:spcAft>
-              <a:defRPr sz="1600">
-                <a:solidFill>
-                  <a:srgbClr val="1A365D"/>
-                </a:solidFill>
-              </a:defRPr>
-            </a:pPr>
-            <a:r>
-              <a:t>• 36 unit + integration tests (pytest), 100% pass in both privilege modes</a:t>
+              <a:t>• Engine shutdown restores all active contracts (no leaked policies)</a:t>
             </a:r>
           </a:p>
         </p:txBody>

</xml_diff>